<commit_message>
Praesentation API 2 Code-folien
</commit_message>
<xml_diff>
--- a/projektaufgabe_1/Abschlusspraesentation_proj1.pptx
+++ b/projektaufgabe_1/Abschlusspraesentation_proj1.pptx
@@ -5,10 +5,10 @@
     <p:sldMasterId id="2147483672" r:id="rId4"/>
   </p:sldMasterIdLst>
   <p:notesMasterIdLst>
-    <p:notesMasterId r:id="rId14"/>
+    <p:notesMasterId r:id="rId16"/>
   </p:notesMasterIdLst>
   <p:handoutMasterIdLst>
-    <p:handoutMasterId r:id="rId15"/>
+    <p:handoutMasterId r:id="rId17"/>
   </p:handoutMasterIdLst>
   <p:sldIdLst>
     <p:sldId id="256" r:id="rId5"/>
@@ -18,8 +18,10 @@
     <p:sldId id="265" r:id="rId9"/>
     <p:sldId id="266" r:id="rId10"/>
     <p:sldId id="263" r:id="rId11"/>
-    <p:sldId id="260" r:id="rId12"/>
-    <p:sldId id="262" r:id="rId13"/>
+    <p:sldId id="267" r:id="rId12"/>
+    <p:sldId id="268" r:id="rId13"/>
+    <p:sldId id="260" r:id="rId14"/>
+    <p:sldId id="262" r:id="rId15"/>
   </p:sldIdLst>
   <p:sldSz cx="12192000" cy="6858000"/>
   <p:notesSz cx="6858000" cy="9144000"/>
@@ -142,7 +144,7 @@
   <pc:docChgLst>
     <pc:chgData name="David Ottino" userId="2e8b103f4c6c57f6" providerId="LiveId" clId="{4FBA45C3-B1BF-42F3-969B-7363B7F5A2BB}"/>
     <pc:docChg chg="undo custSel addSld delSld modSld sldOrd">
-      <pc:chgData name="David Ottino" userId="2e8b103f4c6c57f6" providerId="LiveId" clId="{4FBA45C3-B1BF-42F3-969B-7363B7F5A2BB}" dt="2026-04-27T12:07:25.110" v="626"/>
+      <pc:chgData name="David Ottino" userId="2e8b103f4c6c57f6" providerId="LiveId" clId="{4FBA45C3-B1BF-42F3-969B-7363B7F5A2BB}" dt="2026-04-27T12:17:34.626" v="651"/>
       <pc:docMkLst>
         <pc:docMk/>
       </pc:docMkLst>
@@ -308,6 +310,212 @@
             <ac:grpSpMk id="47" creationId="{9A421166-2996-41A7-B094-AE5316F347DD}"/>
           </ac:grpSpMkLst>
         </pc:grpChg>
+      </pc:sldChg>
+      <pc:sldChg chg="addSp delSp modSp add mod">
+        <pc:chgData name="David Ottino" userId="2e8b103f4c6c57f6" providerId="LiveId" clId="{4FBA45C3-B1BF-42F3-969B-7363B7F5A2BB}" dt="2026-04-27T12:16:41.225" v="642" actId="26606"/>
+        <pc:sldMkLst>
+          <pc:docMk/>
+          <pc:sldMk cId="567447768" sldId="267"/>
+        </pc:sldMkLst>
+        <pc:spChg chg="mod ord">
+          <ac:chgData name="David Ottino" userId="2e8b103f4c6c57f6" providerId="LiveId" clId="{4FBA45C3-B1BF-42F3-969B-7363B7F5A2BB}" dt="2026-04-27T12:16:41.225" v="642" actId="26606"/>
+          <ac:spMkLst>
+            <pc:docMk/>
+            <pc:sldMk cId="567447768" sldId="267"/>
+            <ac:spMk id="2" creationId="{0A36710B-EE68-FFF0-09F8-08322FE3CD3C}"/>
+          </ac:spMkLst>
+        </pc:spChg>
+        <pc:spChg chg="add del mod">
+          <ac:chgData name="David Ottino" userId="2e8b103f4c6c57f6" providerId="LiveId" clId="{4FBA45C3-B1BF-42F3-969B-7363B7F5A2BB}" dt="2026-04-27T12:16:41.225" v="642" actId="26606"/>
+          <ac:spMkLst>
+            <pc:docMk/>
+            <pc:sldMk cId="567447768" sldId="267"/>
+            <ac:spMk id="4" creationId="{7A4B9157-7CF9-6EE5-96B1-A3B7F50CC402}"/>
+          </ac:spMkLst>
+        </pc:spChg>
+        <pc:spChg chg="del">
+          <ac:chgData name="David Ottino" userId="2e8b103f4c6c57f6" providerId="LiveId" clId="{4FBA45C3-B1BF-42F3-969B-7363B7F5A2BB}" dt="2026-04-27T12:15:55.605" v="638" actId="478"/>
+          <ac:spMkLst>
+            <pc:docMk/>
+            <pc:sldMk cId="567447768" sldId="267"/>
+            <ac:spMk id="6" creationId="{97078558-B470-2C1A-C3AE-22FFDB3B6EF4}"/>
+          </ac:spMkLst>
+        </pc:spChg>
+        <pc:spChg chg="add">
+          <ac:chgData name="David Ottino" userId="2e8b103f4c6c57f6" providerId="LiveId" clId="{4FBA45C3-B1BF-42F3-969B-7363B7F5A2BB}" dt="2026-04-27T12:16:41.225" v="642" actId="26606"/>
+          <ac:spMkLst>
+            <pc:docMk/>
+            <pc:sldMk cId="567447768" sldId="267"/>
+            <ac:spMk id="12" creationId="{A078A52F-85EA-4C0B-962B-D9D9DD4DD78C}"/>
+          </ac:spMkLst>
+        </pc:spChg>
+        <pc:spChg chg="add">
+          <ac:chgData name="David Ottino" userId="2e8b103f4c6c57f6" providerId="LiveId" clId="{4FBA45C3-B1BF-42F3-969B-7363B7F5A2BB}" dt="2026-04-27T12:16:41.225" v="642" actId="26606"/>
+          <ac:spMkLst>
+            <pc:docMk/>
+            <pc:sldMk cId="567447768" sldId="267"/>
+            <ac:spMk id="14" creationId="{919797D5-5700-4683-B30A-5B4D56CB8270}"/>
+          </ac:spMkLst>
+        </pc:spChg>
+        <pc:spChg chg="add">
+          <ac:chgData name="David Ottino" userId="2e8b103f4c6c57f6" providerId="LiveId" clId="{4FBA45C3-B1BF-42F3-969B-7363B7F5A2BB}" dt="2026-04-27T12:16:41.225" v="642" actId="26606"/>
+          <ac:spMkLst>
+            <pc:docMk/>
+            <pc:sldMk cId="567447768" sldId="267"/>
+            <ac:spMk id="16" creationId="{4856A7B9-9801-42EC-A4C9-7E22A56EF53D}"/>
+          </ac:spMkLst>
+        </pc:spChg>
+        <pc:spChg chg="add">
+          <ac:chgData name="David Ottino" userId="2e8b103f4c6c57f6" providerId="LiveId" clId="{4FBA45C3-B1BF-42F3-969B-7363B7F5A2BB}" dt="2026-04-27T12:16:41.225" v="642" actId="26606"/>
+          <ac:spMkLst>
+            <pc:docMk/>
+            <pc:sldMk cId="567447768" sldId="267"/>
+            <ac:spMk id="18" creationId="{8AD54DB8-C150-4290-85D6-F5B0262BFEEF}"/>
+          </ac:spMkLst>
+        </pc:spChg>
+        <pc:spChg chg="add">
+          <ac:chgData name="David Ottino" userId="2e8b103f4c6c57f6" providerId="LiveId" clId="{4FBA45C3-B1BF-42F3-969B-7363B7F5A2BB}" dt="2026-04-27T12:16:41.225" v="642" actId="26606"/>
+          <ac:spMkLst>
+            <pc:docMk/>
+            <pc:sldMk cId="567447768" sldId="267"/>
+            <ac:spMk id="20" creationId="{379F11E2-8BA5-4C5C-AE7C-361E5EA011FF}"/>
+          </ac:spMkLst>
+        </pc:spChg>
+        <pc:spChg chg="add">
+          <ac:chgData name="David Ottino" userId="2e8b103f4c6c57f6" providerId="LiveId" clId="{4FBA45C3-B1BF-42F3-969B-7363B7F5A2BB}" dt="2026-04-27T12:16:41.225" v="642" actId="26606"/>
+          <ac:spMkLst>
+            <pc:docMk/>
+            <pc:sldMk cId="567447768" sldId="267"/>
+            <ac:spMk id="22" creationId="{7C00E1DA-EC7C-40FC-95E3-11FDCD2E4291}"/>
+          </ac:spMkLst>
+        </pc:spChg>
+        <pc:grpChg chg="add">
+          <ac:chgData name="David Ottino" userId="2e8b103f4c6c57f6" providerId="LiveId" clId="{4FBA45C3-B1BF-42F3-969B-7363B7F5A2BB}" dt="2026-04-27T12:16:41.225" v="642" actId="26606"/>
+          <ac:grpSpMkLst>
+            <pc:docMk/>
+            <pc:sldMk cId="567447768" sldId="267"/>
+            <ac:grpSpMk id="24" creationId="{9A421166-2996-41A7-B094-AE5316F347DD}"/>
+          </ac:grpSpMkLst>
+        </pc:grpChg>
+        <pc:picChg chg="add mod">
+          <ac:chgData name="David Ottino" userId="2e8b103f4c6c57f6" providerId="LiveId" clId="{4FBA45C3-B1BF-42F3-969B-7363B7F5A2BB}" dt="2026-04-27T12:16:41.225" v="642" actId="26606"/>
+          <ac:picMkLst>
+            <pc:docMk/>
+            <pc:sldMk cId="567447768" sldId="267"/>
+            <ac:picMk id="7" creationId="{2C21C568-C9B8-4D3B-E123-497C2DB3DB86}"/>
+          </ac:picMkLst>
+        </pc:picChg>
+      </pc:sldChg>
+      <pc:sldChg chg="addSp delSp modSp add mod addAnim">
+        <pc:chgData name="David Ottino" userId="2e8b103f4c6c57f6" providerId="LiveId" clId="{4FBA45C3-B1BF-42F3-969B-7363B7F5A2BB}" dt="2026-04-27T12:17:34.626" v="651"/>
+        <pc:sldMkLst>
+          <pc:docMk/>
+          <pc:sldMk cId="2045613644" sldId="268"/>
+        </pc:sldMkLst>
+        <pc:spChg chg="mod ord">
+          <ac:chgData name="David Ottino" userId="2e8b103f4c6c57f6" providerId="LiveId" clId="{4FBA45C3-B1BF-42F3-969B-7363B7F5A2BB}" dt="2026-04-27T12:17:34.610" v="650" actId="26606"/>
+          <ac:spMkLst>
+            <pc:docMk/>
+            <pc:sldMk cId="2045613644" sldId="268"/>
+            <ac:spMk id="2" creationId="{176DFBAE-5471-E50C-F7BA-BA95A0C276DF}"/>
+          </ac:spMkLst>
+        </pc:spChg>
+        <pc:spChg chg="add del mod">
+          <ac:chgData name="David Ottino" userId="2e8b103f4c6c57f6" providerId="LiveId" clId="{4FBA45C3-B1BF-42F3-969B-7363B7F5A2BB}" dt="2026-04-27T12:17:01.759" v="645" actId="478"/>
+          <ac:spMkLst>
+            <pc:docMk/>
+            <pc:sldMk cId="2045613644" sldId="268"/>
+            <ac:spMk id="4" creationId="{19DC58BA-38F6-1B27-CAE2-98D12DFCAFD5}"/>
+          </ac:spMkLst>
+        </pc:spChg>
+        <pc:spChg chg="del">
+          <ac:chgData name="David Ottino" userId="2e8b103f4c6c57f6" providerId="LiveId" clId="{4FBA45C3-B1BF-42F3-969B-7363B7F5A2BB}" dt="2026-04-27T12:17:34.610" v="650" actId="26606"/>
+          <ac:spMkLst>
+            <pc:docMk/>
+            <pc:sldMk cId="2045613644" sldId="268"/>
+            <ac:spMk id="12" creationId="{8636DC44-31E8-EBAB-D4D5-F519A17BEF1D}"/>
+          </ac:spMkLst>
+        </pc:spChg>
+        <pc:spChg chg="del">
+          <ac:chgData name="David Ottino" userId="2e8b103f4c6c57f6" providerId="LiveId" clId="{4FBA45C3-B1BF-42F3-969B-7363B7F5A2BB}" dt="2026-04-27T12:17:34.610" v="650" actId="26606"/>
+          <ac:spMkLst>
+            <pc:docMk/>
+            <pc:sldMk cId="2045613644" sldId="268"/>
+            <ac:spMk id="18" creationId="{634FCC80-748E-E143-4001-EC7271DC5749}"/>
+          </ac:spMkLst>
+        </pc:spChg>
+        <pc:spChg chg="del">
+          <ac:chgData name="David Ottino" userId="2e8b103f4c6c57f6" providerId="LiveId" clId="{4FBA45C3-B1BF-42F3-969B-7363B7F5A2BB}" dt="2026-04-27T12:17:34.610" v="650" actId="26606"/>
+          <ac:spMkLst>
+            <pc:docMk/>
+            <pc:sldMk cId="2045613644" sldId="268"/>
+            <ac:spMk id="20" creationId="{D68E5DDA-28C0-E3BD-D60C-9096B10CB640}"/>
+          </ac:spMkLst>
+        </pc:spChg>
+        <pc:spChg chg="del">
+          <ac:chgData name="David Ottino" userId="2e8b103f4c6c57f6" providerId="LiveId" clId="{4FBA45C3-B1BF-42F3-969B-7363B7F5A2BB}" dt="2026-04-27T12:17:34.610" v="650" actId="26606"/>
+          <ac:spMkLst>
+            <pc:docMk/>
+            <pc:sldMk cId="2045613644" sldId="268"/>
+            <ac:spMk id="22" creationId="{8D120D35-C648-2891-4B4B-5AF073B8A264}"/>
+          </ac:spMkLst>
+        </pc:spChg>
+        <pc:spChg chg="add">
+          <ac:chgData name="David Ottino" userId="2e8b103f4c6c57f6" providerId="LiveId" clId="{4FBA45C3-B1BF-42F3-969B-7363B7F5A2BB}" dt="2026-04-27T12:17:34.610" v="650" actId="26606"/>
+          <ac:spMkLst>
+            <pc:docMk/>
+            <pc:sldMk cId="2045613644" sldId="268"/>
+            <ac:spMk id="32" creationId="{A078A52F-85EA-4C0B-962B-D9D9DD4DD78C}"/>
+          </ac:spMkLst>
+        </pc:spChg>
+        <pc:spChg chg="add">
+          <ac:chgData name="David Ottino" userId="2e8b103f4c6c57f6" providerId="LiveId" clId="{4FBA45C3-B1BF-42F3-969B-7363B7F5A2BB}" dt="2026-04-27T12:17:34.610" v="650" actId="26606"/>
+          <ac:spMkLst>
+            <pc:docMk/>
+            <pc:sldMk cId="2045613644" sldId="268"/>
+            <ac:spMk id="34" creationId="{919797D5-5700-4683-B30A-5B4D56CB8270}"/>
+          </ac:spMkLst>
+        </pc:spChg>
+        <pc:spChg chg="add">
+          <ac:chgData name="David Ottino" userId="2e8b103f4c6c57f6" providerId="LiveId" clId="{4FBA45C3-B1BF-42F3-969B-7363B7F5A2BB}" dt="2026-04-27T12:17:34.610" v="650" actId="26606"/>
+          <ac:spMkLst>
+            <pc:docMk/>
+            <pc:sldMk cId="2045613644" sldId="268"/>
+            <ac:spMk id="38" creationId="{8AD54DB8-C150-4290-85D6-F5B0262BFEEF}"/>
+          </ac:spMkLst>
+        </pc:spChg>
+        <pc:spChg chg="add">
+          <ac:chgData name="David Ottino" userId="2e8b103f4c6c57f6" providerId="LiveId" clId="{4FBA45C3-B1BF-42F3-969B-7363B7F5A2BB}" dt="2026-04-27T12:17:34.610" v="650" actId="26606"/>
+          <ac:spMkLst>
+            <pc:docMk/>
+            <pc:sldMk cId="2045613644" sldId="268"/>
+            <ac:spMk id="40" creationId="{379F11E2-8BA5-4C5C-AE7C-361E5EA011FF}"/>
+          </ac:spMkLst>
+        </pc:spChg>
+        <pc:spChg chg="add">
+          <ac:chgData name="David Ottino" userId="2e8b103f4c6c57f6" providerId="LiveId" clId="{4FBA45C3-B1BF-42F3-969B-7363B7F5A2BB}" dt="2026-04-27T12:17:34.610" v="650" actId="26606"/>
+          <ac:spMkLst>
+            <pc:docMk/>
+            <pc:sldMk cId="2045613644" sldId="268"/>
+            <ac:spMk id="42" creationId="{7C00E1DA-EC7C-40FC-95E3-11FDCD2E4291}"/>
+          </ac:spMkLst>
+        </pc:spChg>
+        <pc:picChg chg="add mod">
+          <ac:chgData name="David Ottino" userId="2e8b103f4c6c57f6" providerId="LiveId" clId="{4FBA45C3-B1BF-42F3-969B-7363B7F5A2BB}" dt="2026-04-27T12:17:33.785" v="649" actId="14100"/>
+          <ac:picMkLst>
+            <pc:docMk/>
+            <pc:sldMk cId="2045613644" sldId="268"/>
+            <ac:picMk id="6" creationId="{72EA7E18-3D88-A852-0D32-2BF964766F48}"/>
+          </ac:picMkLst>
+        </pc:picChg>
+        <pc:picChg chg="del">
+          <ac:chgData name="David Ottino" userId="2e8b103f4c6c57f6" providerId="LiveId" clId="{4FBA45C3-B1BF-42F3-969B-7363B7F5A2BB}" dt="2026-04-27T12:16:53.034" v="644" actId="478"/>
+          <ac:picMkLst>
+            <pc:docMk/>
+            <pc:sldMk cId="2045613644" sldId="268"/>
+            <ac:picMk id="7" creationId="{577BA31A-5E11-CE2E-DDE4-412948E26E8B}"/>
+          </ac:picMkLst>
+        </pc:picChg>
       </pc:sldChg>
     </pc:docChg>
   </pc:docChgLst>
@@ -4733,6 +4941,198 @@
 </p:notes>
 </file>
 
+<file path=ppt/notesSlides/notesSlide10.xml><?xml version="1.0" encoding="utf-8"?>
+<p:notes xmlns:a="http://schemas.openxmlformats.org/drawingml/2006/main" xmlns:r="http://schemas.openxmlformats.org/officeDocument/2006/relationships" xmlns:p="http://schemas.openxmlformats.org/presentationml/2006/main">
+  <p:cSld>
+    <p:spTree>
+      <p:nvGrpSpPr>
+        <p:cNvPr id="1" name=""/>
+        <p:cNvGrpSpPr/>
+        <p:nvPr/>
+      </p:nvGrpSpPr>
+      <p:grpSpPr>
+        <a:xfrm>
+          <a:off x="0" y="0"/>
+          <a:ext cx="0" cy="0"/>
+          <a:chOff x="0" y="0"/>
+          <a:chExt cx="0" cy="0"/>
+        </a:xfrm>
+      </p:grpSpPr>
+      <p:sp>
+        <p:nvSpPr>
+          <p:cNvPr id="2" name="Folienbildplatzhalter 1"/>
+          <p:cNvSpPr>
+            <a:spLocks noGrp="1" noRot="1" noChangeAspect="1"/>
+          </p:cNvSpPr>
+          <p:nvPr>
+            <p:ph type="sldImg"/>
+          </p:nvPr>
+        </p:nvSpPr>
+        <p:spPr/>
+      </p:sp>
+      <p:sp>
+        <p:nvSpPr>
+          <p:cNvPr id="3" name="Notizenplatzhalter 2"/>
+          <p:cNvSpPr>
+            <a:spLocks noGrp="1"/>
+          </p:cNvSpPr>
+          <p:nvPr>
+            <p:ph type="body" idx="1"/>
+          </p:nvPr>
+        </p:nvSpPr>
+        <p:spPr/>
+        <p:txBody>
+          <a:bodyPr/>
+          <a:lstStyle/>
+          <a:p>
+            <a:endParaRPr lang="de-DE"/>
+          </a:p>
+        </p:txBody>
+      </p:sp>
+      <p:sp>
+        <p:nvSpPr>
+          <p:cNvPr id="4" name="Foliennummernplatzhalter 3"/>
+          <p:cNvSpPr>
+            <a:spLocks noGrp="1"/>
+          </p:cNvSpPr>
+          <p:nvPr>
+            <p:ph type="sldNum" sz="quarter" idx="5"/>
+          </p:nvPr>
+        </p:nvSpPr>
+        <p:spPr/>
+        <p:txBody>
+          <a:bodyPr/>
+          <a:lstStyle/>
+          <a:p>
+            <a:fld id="{DEF059D1-1E64-4095-816B-E25F58AA521B}" type="slidenum">
+              <a:rPr lang="de-DE" smtClean="0"/>
+              <a:t>10</a:t>
+            </a:fld>
+            <a:endParaRPr lang="de-DE"/>
+          </a:p>
+        </p:txBody>
+      </p:sp>
+    </p:spTree>
+    <p:extLst>
+      <p:ext uri="{BB962C8B-B14F-4D97-AF65-F5344CB8AC3E}">
+        <p14:creationId xmlns:p14="http://schemas.microsoft.com/office/powerpoint/2010/main" val="1722163809"/>
+      </p:ext>
+    </p:extLst>
+  </p:cSld>
+  <p:clrMapOvr>
+    <a:masterClrMapping/>
+  </p:clrMapOvr>
+</p:notes>
+</file>
+
+<file path=ppt/notesSlides/notesSlide11.xml><?xml version="1.0" encoding="utf-8"?>
+<p:notes xmlns:a="http://schemas.openxmlformats.org/drawingml/2006/main" xmlns:r="http://schemas.openxmlformats.org/officeDocument/2006/relationships" xmlns:p="http://schemas.openxmlformats.org/presentationml/2006/main">
+  <p:cSld>
+    <p:spTree>
+      <p:nvGrpSpPr>
+        <p:cNvPr id="1" name="">
+          <a:extLst>
+            <a:ext uri="{FF2B5EF4-FFF2-40B4-BE49-F238E27FC236}">
+              <a16:creationId xmlns:a16="http://schemas.microsoft.com/office/drawing/2014/main" id="{07402912-FD73-6D93-1036-687993C00CFF}"/>
+            </a:ext>
+          </a:extLst>
+        </p:cNvPr>
+        <p:cNvGrpSpPr/>
+        <p:nvPr/>
+      </p:nvGrpSpPr>
+      <p:grpSpPr>
+        <a:xfrm>
+          <a:off x="0" y="0"/>
+          <a:ext cx="0" cy="0"/>
+          <a:chOff x="0" y="0"/>
+          <a:chExt cx="0" cy="0"/>
+        </a:xfrm>
+      </p:grpSpPr>
+      <p:sp>
+        <p:nvSpPr>
+          <p:cNvPr id="2" name="Folienbildplatzhalter 1">
+            <a:extLst>
+              <a:ext uri="{FF2B5EF4-FFF2-40B4-BE49-F238E27FC236}">
+                <a16:creationId xmlns:a16="http://schemas.microsoft.com/office/drawing/2014/main" id="{43EF5B76-200E-49A5-8BC8-59A4AE94B9EC}"/>
+              </a:ext>
+            </a:extLst>
+          </p:cNvPr>
+          <p:cNvSpPr>
+            <a:spLocks noGrp="1" noRot="1" noChangeAspect="1"/>
+          </p:cNvSpPr>
+          <p:nvPr>
+            <p:ph type="sldImg"/>
+          </p:nvPr>
+        </p:nvSpPr>
+        <p:spPr/>
+      </p:sp>
+      <p:sp>
+        <p:nvSpPr>
+          <p:cNvPr id="3" name="Notizenplatzhalter 2">
+            <a:extLst>
+              <a:ext uri="{FF2B5EF4-FFF2-40B4-BE49-F238E27FC236}">
+                <a16:creationId xmlns:a16="http://schemas.microsoft.com/office/drawing/2014/main" id="{96ABCAC8-6B02-A470-8D14-A9D675E1DD09}"/>
+              </a:ext>
+            </a:extLst>
+          </p:cNvPr>
+          <p:cNvSpPr>
+            <a:spLocks noGrp="1"/>
+          </p:cNvSpPr>
+          <p:nvPr>
+            <p:ph type="body" idx="1"/>
+          </p:nvPr>
+        </p:nvSpPr>
+        <p:spPr/>
+        <p:txBody>
+          <a:bodyPr/>
+          <a:lstStyle/>
+          <a:p>
+            <a:endParaRPr lang="de-DE"/>
+          </a:p>
+        </p:txBody>
+      </p:sp>
+      <p:sp>
+        <p:nvSpPr>
+          <p:cNvPr id="4" name="Foliennummernplatzhalter 3">
+            <a:extLst>
+              <a:ext uri="{FF2B5EF4-FFF2-40B4-BE49-F238E27FC236}">
+                <a16:creationId xmlns:a16="http://schemas.microsoft.com/office/drawing/2014/main" id="{5BE433D6-FEF0-EA7F-1D4F-F4FBE685FEB6}"/>
+              </a:ext>
+            </a:extLst>
+          </p:cNvPr>
+          <p:cNvSpPr>
+            <a:spLocks noGrp="1"/>
+          </p:cNvSpPr>
+          <p:nvPr>
+            <p:ph type="sldNum" sz="quarter" idx="5"/>
+          </p:nvPr>
+        </p:nvSpPr>
+        <p:spPr/>
+        <p:txBody>
+          <a:bodyPr/>
+          <a:lstStyle/>
+          <a:p>
+            <a:fld id="{DEF059D1-1E64-4095-816B-E25F58AA521B}" type="slidenum">
+              <a:rPr lang="de-DE" smtClean="0"/>
+              <a:t>11</a:t>
+            </a:fld>
+            <a:endParaRPr lang="de-DE"/>
+          </a:p>
+        </p:txBody>
+      </p:sp>
+    </p:spTree>
+    <p:extLst>
+      <p:ext uri="{BB962C8B-B14F-4D97-AF65-F5344CB8AC3E}">
+        <p14:creationId xmlns:p14="http://schemas.microsoft.com/office/powerpoint/2010/main" val="3916977617"/>
+      </p:ext>
+    </p:extLst>
+  </p:cSld>
+  <p:clrMapOvr>
+    <a:masterClrMapping/>
+  </p:clrMapOvr>
+</p:notes>
+</file>
+
 <file path=ppt/notesSlides/notesSlide2.xml><?xml version="1.0" encoding="utf-8"?>
 <p:notes xmlns:a="http://schemas.openxmlformats.org/drawingml/2006/main" xmlns:r="http://schemas.openxmlformats.org/officeDocument/2006/relationships" xmlns:p="http://schemas.openxmlformats.org/presentationml/2006/main">
   <p:cSld>
@@ -5338,7 +5738,13 @@
   <p:cSld>
     <p:spTree>
       <p:nvGrpSpPr>
-        <p:cNvPr id="1" name=""/>
+        <p:cNvPr id="1" name="">
+          <a:extLst>
+            <a:ext uri="{FF2B5EF4-FFF2-40B4-BE49-F238E27FC236}">
+              <a16:creationId xmlns:a16="http://schemas.microsoft.com/office/drawing/2014/main" id="{81B23F08-9B1A-638F-0305-C74572CDFDE1}"/>
+            </a:ext>
+          </a:extLst>
+        </p:cNvPr>
         <p:cNvGrpSpPr/>
         <p:nvPr/>
       </p:nvGrpSpPr>
@@ -5352,7 +5758,13 @@
       </p:grpSpPr>
       <p:sp>
         <p:nvSpPr>
-          <p:cNvPr id="2" name="Folienbildplatzhalter 1"/>
+          <p:cNvPr id="2" name="Folienbildplatzhalter 1">
+            <a:extLst>
+              <a:ext uri="{FF2B5EF4-FFF2-40B4-BE49-F238E27FC236}">
+                <a16:creationId xmlns:a16="http://schemas.microsoft.com/office/drawing/2014/main" id="{DF9F1B26-9E5F-64B3-A936-FFC249AB1845}"/>
+              </a:ext>
+            </a:extLst>
+          </p:cNvPr>
           <p:cNvSpPr>
             <a:spLocks noGrp="1" noRot="1" noChangeAspect="1"/>
           </p:cNvSpPr>
@@ -5364,7 +5776,13 @@
       </p:sp>
       <p:sp>
         <p:nvSpPr>
-          <p:cNvPr id="3" name="Notizenplatzhalter 2"/>
+          <p:cNvPr id="3" name="Notizenplatzhalter 2">
+            <a:extLst>
+              <a:ext uri="{FF2B5EF4-FFF2-40B4-BE49-F238E27FC236}">
+                <a16:creationId xmlns:a16="http://schemas.microsoft.com/office/drawing/2014/main" id="{F6171A45-4EE0-AF74-A88B-FB926621E06D}"/>
+              </a:ext>
+            </a:extLst>
+          </p:cNvPr>
           <p:cNvSpPr>
             <a:spLocks noGrp="1"/>
           </p:cNvSpPr>
@@ -5383,7 +5801,13 @@
       </p:sp>
       <p:sp>
         <p:nvSpPr>
-          <p:cNvPr id="4" name="Foliennummernplatzhalter 3"/>
+          <p:cNvPr id="4" name="Foliennummernplatzhalter 3">
+            <a:extLst>
+              <a:ext uri="{FF2B5EF4-FFF2-40B4-BE49-F238E27FC236}">
+                <a16:creationId xmlns:a16="http://schemas.microsoft.com/office/drawing/2014/main" id="{D2BD3A16-FB95-D1CF-A010-82A02715F4DC}"/>
+              </a:ext>
+            </a:extLst>
+          </p:cNvPr>
           <p:cNvSpPr>
             <a:spLocks noGrp="1"/>
           </p:cNvSpPr>
@@ -5407,7 +5831,7 @@
     </p:spTree>
     <p:extLst>
       <p:ext uri="{BB962C8B-B14F-4D97-AF65-F5344CB8AC3E}">
-        <p14:creationId xmlns:p14="http://schemas.microsoft.com/office/powerpoint/2010/main" val="1722163809"/>
+        <p14:creationId xmlns:p14="http://schemas.microsoft.com/office/powerpoint/2010/main" val="3282144631"/>
       </p:ext>
     </p:extLst>
   </p:cSld>
@@ -5425,7 +5849,7 @@
         <p:cNvPr id="1" name="">
           <a:extLst>
             <a:ext uri="{FF2B5EF4-FFF2-40B4-BE49-F238E27FC236}">
-              <a16:creationId xmlns:a16="http://schemas.microsoft.com/office/drawing/2014/main" id="{07402912-FD73-6D93-1036-687993C00CFF}"/>
+              <a16:creationId xmlns:a16="http://schemas.microsoft.com/office/drawing/2014/main" id="{551F245D-440E-A2CC-48FB-E69D995909BA}"/>
             </a:ext>
           </a:extLst>
         </p:cNvPr>
@@ -5445,7 +5869,7 @@
           <p:cNvPr id="2" name="Folienbildplatzhalter 1">
             <a:extLst>
               <a:ext uri="{FF2B5EF4-FFF2-40B4-BE49-F238E27FC236}">
-                <a16:creationId xmlns:a16="http://schemas.microsoft.com/office/drawing/2014/main" id="{43EF5B76-200E-49A5-8BC8-59A4AE94B9EC}"/>
+                <a16:creationId xmlns:a16="http://schemas.microsoft.com/office/drawing/2014/main" id="{2F5F2733-C1DA-74C2-DB92-E1788D08AA65}"/>
               </a:ext>
             </a:extLst>
           </p:cNvPr>
@@ -5463,7 +5887,7 @@
           <p:cNvPr id="3" name="Notizenplatzhalter 2">
             <a:extLst>
               <a:ext uri="{FF2B5EF4-FFF2-40B4-BE49-F238E27FC236}">
-                <a16:creationId xmlns:a16="http://schemas.microsoft.com/office/drawing/2014/main" id="{96ABCAC8-6B02-A470-8D14-A9D675E1DD09}"/>
+                <a16:creationId xmlns:a16="http://schemas.microsoft.com/office/drawing/2014/main" id="{C333A0E4-523C-0F44-15E7-2157422AE0E0}"/>
               </a:ext>
             </a:extLst>
           </p:cNvPr>
@@ -5488,7 +5912,7 @@
           <p:cNvPr id="4" name="Foliennummernplatzhalter 3">
             <a:extLst>
               <a:ext uri="{FF2B5EF4-FFF2-40B4-BE49-F238E27FC236}">
-                <a16:creationId xmlns:a16="http://schemas.microsoft.com/office/drawing/2014/main" id="{5BE433D6-FEF0-EA7F-1D4F-F4FBE685FEB6}"/>
+                <a16:creationId xmlns:a16="http://schemas.microsoft.com/office/drawing/2014/main" id="{AD92301E-49AA-EE22-00DC-EAEC6A7EE4AA}"/>
               </a:ext>
             </a:extLst>
           </p:cNvPr>
@@ -5515,7 +5939,7 @@
     </p:spTree>
     <p:extLst>
       <p:ext uri="{BB962C8B-B14F-4D97-AF65-F5344CB8AC3E}">
-        <p14:creationId xmlns:p14="http://schemas.microsoft.com/office/powerpoint/2010/main" val="3916977617"/>
+        <p14:creationId xmlns:p14="http://schemas.microsoft.com/office/powerpoint/2010/main" val="635035726"/>
       </p:ext>
     </p:extLst>
   </p:cSld>
@@ -9848,6 +10272,581 @@
 </p:sld>
 </file>
 
+<file path=ppt/slides/slide10.xml><?xml version="1.0" encoding="utf-8"?>
+<p:sld xmlns:a="http://schemas.openxmlformats.org/drawingml/2006/main" xmlns:r="http://schemas.openxmlformats.org/officeDocument/2006/relationships" xmlns:p="http://schemas.openxmlformats.org/presentationml/2006/main">
+  <p:cSld>
+    <p:bg>
+      <p:bgPr>
+        <a:solidFill>
+          <a:schemeClr val="bg1"/>
+        </a:solidFill>
+        <a:effectLst/>
+      </p:bgPr>
+    </p:bg>
+    <p:spTree>
+      <p:nvGrpSpPr>
+        <p:cNvPr id="1" name=""/>
+        <p:cNvGrpSpPr/>
+        <p:nvPr/>
+      </p:nvGrpSpPr>
+      <p:grpSpPr>
+        <a:xfrm>
+          <a:off x="0" y="0"/>
+          <a:ext cx="0" cy="0"/>
+          <a:chOff x="0" y="0"/>
+          <a:chExt cx="0" cy="0"/>
+        </a:xfrm>
+      </p:grpSpPr>
+      <p:sp useBgFill="1">
+        <p:nvSpPr>
+          <p:cNvPr id="10" name="Rechteck 9">
+            <a:extLst>
+              <a:ext uri="{FF2B5EF4-FFF2-40B4-BE49-F238E27FC236}">
+                <a16:creationId xmlns:a16="http://schemas.microsoft.com/office/drawing/2014/main" id="{379F11E2-8BA5-4C5C-AE7C-361E5EA011FF}"/>
+              </a:ext>
+              <a:ext uri="{C183D7F6-B498-43B3-948B-1728B52AA6E4}">
+                <adec:decorative xmlns:adec="http://schemas.microsoft.com/office/drawing/2017/decorative" val="1"/>
+              </a:ext>
+            </a:extLst>
+          </p:cNvPr>
+          <p:cNvSpPr>
+            <a:spLocks noGrp="1" noRot="1" noChangeAspect="1" noMove="1" noResize="1" noEditPoints="1" noAdjustHandles="1" noChangeArrowheads="1" noChangeShapeType="1" noTextEdit="1"/>
+          </p:cNvSpPr>
+          <p:nvPr>
+            <p:extLst>
+              <p:ext uri="{386F3935-93C4-4BCD-93E2-E3B085C9AB24}">
+                <p16:designElem xmlns:p16="http://schemas.microsoft.com/office/powerpoint/2015/main" val="1"/>
+              </p:ext>
+            </p:extLst>
+          </p:nvPr>
+        </p:nvSpPr>
+        <p:spPr>
+          <a:xfrm>
+            <a:off x="0" y="1"/>
+            <a:ext cx="12191999" cy="6858000"/>
+          </a:xfrm>
+          <a:prstGeom prst="rect">
+            <a:avLst/>
+          </a:prstGeom>
+          <a:ln>
+            <a:noFill/>
+          </a:ln>
+        </p:spPr>
+        <p:style>
+          <a:lnRef idx="2">
+            <a:schemeClr val="accent1">
+              <a:shade val="50000"/>
+            </a:schemeClr>
+          </a:lnRef>
+          <a:fillRef idx="1">
+            <a:schemeClr val="accent1"/>
+          </a:fillRef>
+          <a:effectRef idx="0">
+            <a:schemeClr val="accent1"/>
+          </a:effectRef>
+          <a:fontRef idx="minor">
+            <a:schemeClr val="lt1"/>
+          </a:fontRef>
+        </p:style>
+        <p:txBody>
+          <a:bodyPr rtlCol="0" anchor="ctr"/>
+          <a:lstStyle/>
+          <a:p>
+            <a:pPr algn="ctr" rtl="0"/>
+            <a:endParaRPr lang="de-DE"/>
+          </a:p>
+        </p:txBody>
+      </p:sp>
+      <p:pic>
+        <p:nvPicPr>
+          <p:cNvPr id="5" name="Bild 4" descr="Digitale Zahlen">
+            <a:extLst>
+              <a:ext uri="{FF2B5EF4-FFF2-40B4-BE49-F238E27FC236}">
+                <a16:creationId xmlns:a16="http://schemas.microsoft.com/office/drawing/2014/main" id="{A21EA617-6D48-425F-97A8-7FEC82C8F401}"/>
+              </a:ext>
+            </a:extLst>
+          </p:cNvPr>
+          <p:cNvPicPr>
+            <a:picLocks noChangeAspect="1"/>
+          </p:cNvPicPr>
+          <p:nvPr/>
+        </p:nvPicPr>
+        <p:blipFill rotWithShape="1">
+          <a:blip r:embed="rId3" cstate="screen">
+            <a:extLst>
+              <a:ext uri="{28A0092B-C50C-407E-A947-70E740481C1C}">
+                <a14:useLocalDpi xmlns:a14="http://schemas.microsoft.com/office/drawing/2010/main"/>
+              </a:ext>
+            </a:extLst>
+          </a:blip>
+          <a:srcRect l="2189" r="9642" b="1"/>
+          <a:stretch/>
+        </p:blipFill>
+        <p:spPr>
+          <a:xfrm>
+            <a:off x="446534" y="723899"/>
+            <a:ext cx="7498616" cy="5676901"/>
+          </a:xfrm>
+          <a:prstGeom prst="rect">
+            <a:avLst/>
+          </a:prstGeom>
+        </p:spPr>
+      </p:pic>
+      <p:sp>
+        <p:nvSpPr>
+          <p:cNvPr id="12" name="Rechteck 11">
+            <a:extLst>
+              <a:ext uri="{FF2B5EF4-FFF2-40B4-BE49-F238E27FC236}">
+                <a16:creationId xmlns:a16="http://schemas.microsoft.com/office/drawing/2014/main" id="{7C00E1DA-EC7C-40FC-95E3-11FDCD2E4291}"/>
+              </a:ext>
+              <a:ext uri="{C183D7F6-B498-43B3-948B-1728B52AA6E4}">
+                <adec:decorative xmlns:adec="http://schemas.microsoft.com/office/drawing/2017/decorative" val="1"/>
+              </a:ext>
+            </a:extLst>
+          </p:cNvPr>
+          <p:cNvSpPr>
+            <a:spLocks noGrp="1" noRot="1" noChangeAspect="1" noMove="1" noResize="1" noEditPoints="1" noAdjustHandles="1" noChangeArrowheads="1" noChangeShapeType="1" noTextEdit="1"/>
+          </p:cNvSpPr>
+          <p:nvPr>
+            <p:extLst>
+              <p:ext uri="{386F3935-93C4-4BCD-93E2-E3B085C9AB24}">
+                <p16:designElem xmlns:p16="http://schemas.microsoft.com/office/powerpoint/2015/main" val="1"/>
+              </p:ext>
+            </p:extLst>
+          </p:nvPr>
+        </p:nvSpPr>
+        <p:spPr>
+          <a:xfrm>
+            <a:off x="8042147" y="723899"/>
+            <a:ext cx="3703320" cy="5666666"/>
+          </a:xfrm>
+          <a:prstGeom prst="rect">
+            <a:avLst/>
+          </a:prstGeom>
+          <a:solidFill>
+            <a:schemeClr val="accent1"/>
+          </a:solidFill>
+          <a:ln>
+            <a:noFill/>
+          </a:ln>
+          <a:effectLst/>
+        </p:spPr>
+        <p:style>
+          <a:lnRef idx="1">
+            <a:schemeClr val="accent1"/>
+          </a:lnRef>
+          <a:fillRef idx="3">
+            <a:schemeClr val="accent1"/>
+          </a:fillRef>
+          <a:effectRef idx="2">
+            <a:schemeClr val="accent1"/>
+          </a:effectRef>
+          <a:fontRef idx="minor">
+            <a:schemeClr val="lt1"/>
+          </a:fontRef>
+        </p:style>
+        <p:txBody>
+          <a:bodyPr/>
+          <a:lstStyle/>
+          <a:p>
+            <a:endParaRPr lang="de-AT"/>
+          </a:p>
+        </p:txBody>
+      </p:sp>
+      <p:sp>
+        <p:nvSpPr>
+          <p:cNvPr id="2" name="Titel 1">
+            <a:extLst>
+              <a:ext uri="{FF2B5EF4-FFF2-40B4-BE49-F238E27FC236}">
+                <a16:creationId xmlns:a16="http://schemas.microsoft.com/office/drawing/2014/main" id="{0F87E73C-2B1A-4602-BFBE-CFE1E55D9B38}"/>
+              </a:ext>
+            </a:extLst>
+          </p:cNvPr>
+          <p:cNvSpPr>
+            <a:spLocks noGrp="1"/>
+          </p:cNvSpPr>
+          <p:nvPr>
+            <p:ph type="ctrTitle"/>
+          </p:nvPr>
+        </p:nvSpPr>
+        <p:spPr>
+          <a:xfrm>
+            <a:off x="8296275" y="1419226"/>
+            <a:ext cx="3081576" cy="1746762"/>
+          </a:xfrm>
+        </p:spPr>
+        <p:txBody>
+          <a:bodyPr rtlCol="0">
+            <a:normAutofit/>
+          </a:bodyPr>
+          <a:lstStyle/>
+          <a:p>
+            <a:pPr rtl="0"/>
+            <a:r>
+              <a:rPr lang="de-DE" dirty="0">
+                <a:solidFill>
+                  <a:srgbClr val="FFFFFF"/>
+                </a:solidFill>
+              </a:rPr>
+              <a:t>Demo</a:t>
+            </a:r>
+          </a:p>
+        </p:txBody>
+      </p:sp>
+      <p:grpSp>
+        <p:nvGrpSpPr>
+          <p:cNvPr id="14" name="Gruppe 13">
+            <a:extLst>
+              <a:ext uri="{FF2B5EF4-FFF2-40B4-BE49-F238E27FC236}">
+                <a16:creationId xmlns:a16="http://schemas.microsoft.com/office/drawing/2014/main" id="{9A421166-2996-41A7-B094-AE5316F347DD}"/>
+              </a:ext>
+              <a:ext uri="{C183D7F6-B498-43B3-948B-1728B52AA6E4}">
+                <adec:decorative xmlns:adec="http://schemas.microsoft.com/office/drawing/2017/decorative" val="1"/>
+              </a:ext>
+            </a:extLst>
+          </p:cNvPr>
+          <p:cNvGrpSpPr>
+            <a:grpSpLocks noGrp="1" noUngrp="1" noRot="1" noChangeAspect="1" noMove="1" noResize="1"/>
+          </p:cNvGrpSpPr>
+          <p:nvPr>
+            <p:extLst>
+              <p:ext uri="{386F3935-93C4-4BCD-93E2-E3B085C9AB24}">
+                <p16:designElem xmlns:p16="http://schemas.microsoft.com/office/powerpoint/2015/main" val="1"/>
+              </p:ext>
+            </p:extLst>
+          </p:nvPr>
+        </p:nvGrpSpPr>
+        <p:grpSpPr>
+          <a:xfrm>
+            <a:off x="446534" y="453643"/>
+            <a:ext cx="11298933" cy="98554"/>
+            <a:chOff x="446534" y="453643"/>
+            <a:chExt cx="11298933" cy="98554"/>
+          </a:xfrm>
+        </p:grpSpPr>
+        <p:sp>
+          <p:nvSpPr>
+            <p:cNvPr id="15" name="Rechteck 14">
+              <a:extLst>
+                <a:ext uri="{FF2B5EF4-FFF2-40B4-BE49-F238E27FC236}">
+                  <a16:creationId xmlns:a16="http://schemas.microsoft.com/office/drawing/2014/main" id="{FDBB1B92-A3EB-43E4-8FAB-D20E8ED14CEF}"/>
+                </a:ext>
+                <a:ext uri="{C183D7F6-B498-43B3-948B-1728B52AA6E4}">
+                  <adec:decorative xmlns:adec="http://schemas.microsoft.com/office/drawing/2017/decorative" val="1"/>
+                </a:ext>
+              </a:extLst>
+            </p:cNvPr>
+            <p:cNvSpPr/>
+            <p:nvPr>
+              <p:extLst>
+                <p:ext uri="{386F3935-93C4-4BCD-93E2-E3B085C9AB24}">
+                  <p16:designElem xmlns:p16="http://schemas.microsoft.com/office/powerpoint/2015/main" val="1"/>
+                </p:ext>
+              </p:extLst>
+            </p:nvPr>
+          </p:nvSpPr>
+          <p:spPr>
+            <a:xfrm>
+              <a:off x="446534" y="457200"/>
+              <a:ext cx="3703320" cy="94997"/>
+            </a:xfrm>
+            <a:prstGeom prst="rect">
+              <a:avLst/>
+            </a:prstGeom>
+            <a:solidFill>
+              <a:schemeClr val="accent1"/>
+            </a:solidFill>
+            <a:ln>
+              <a:noFill/>
+            </a:ln>
+            <a:effectLst/>
+          </p:spPr>
+          <p:style>
+            <a:lnRef idx="1">
+              <a:schemeClr val="accent1"/>
+            </a:lnRef>
+            <a:fillRef idx="3">
+              <a:schemeClr val="accent1"/>
+            </a:fillRef>
+            <a:effectRef idx="2">
+              <a:schemeClr val="accent1"/>
+            </a:effectRef>
+            <a:fontRef idx="minor">
+              <a:schemeClr val="lt1"/>
+            </a:fontRef>
+          </p:style>
+          <p:txBody>
+            <a:bodyPr/>
+            <a:lstStyle/>
+            <a:p>
+              <a:endParaRPr lang="de-AT"/>
+            </a:p>
+          </p:txBody>
+        </p:sp>
+        <p:sp>
+          <p:nvSpPr>
+            <p:cNvPr id="16" name="Rechteck 15">
+              <a:extLst>
+                <a:ext uri="{FF2B5EF4-FFF2-40B4-BE49-F238E27FC236}">
+                  <a16:creationId xmlns:a16="http://schemas.microsoft.com/office/drawing/2014/main" id="{3F3972F4-FE7E-48EA-AAD8-9BE5750A6672}"/>
+                </a:ext>
+                <a:ext uri="{C183D7F6-B498-43B3-948B-1728B52AA6E4}">
+                  <adec:decorative xmlns:adec="http://schemas.microsoft.com/office/drawing/2017/decorative" val="1"/>
+                </a:ext>
+              </a:extLst>
+            </p:cNvPr>
+            <p:cNvSpPr/>
+            <p:nvPr>
+              <p:extLst>
+                <p:ext uri="{386F3935-93C4-4BCD-93E2-E3B085C9AB24}">
+                  <p16:designElem xmlns:p16="http://schemas.microsoft.com/office/powerpoint/2015/main" val="1"/>
+                </p:ext>
+              </p:extLst>
+            </p:nvPr>
+          </p:nvSpPr>
+          <p:spPr>
+            <a:xfrm>
+              <a:off x="8042147" y="453643"/>
+              <a:ext cx="3703320" cy="98554"/>
+            </a:xfrm>
+            <a:prstGeom prst="rect">
+              <a:avLst/>
+            </a:prstGeom>
+            <a:solidFill>
+              <a:schemeClr val="accent4"/>
+            </a:solidFill>
+            <a:ln>
+              <a:noFill/>
+            </a:ln>
+            <a:effectLst/>
+          </p:spPr>
+          <p:style>
+            <a:lnRef idx="1">
+              <a:schemeClr val="accent1"/>
+            </a:lnRef>
+            <a:fillRef idx="3">
+              <a:schemeClr val="accent1"/>
+            </a:fillRef>
+            <a:effectRef idx="2">
+              <a:schemeClr val="accent1"/>
+            </a:effectRef>
+            <a:fontRef idx="minor">
+              <a:schemeClr val="lt1"/>
+            </a:fontRef>
+          </p:style>
+          <p:txBody>
+            <a:bodyPr/>
+            <a:lstStyle/>
+            <a:p>
+              <a:endParaRPr lang="de-AT"/>
+            </a:p>
+          </p:txBody>
+        </p:sp>
+        <p:sp>
+          <p:nvSpPr>
+            <p:cNvPr id="17" name="Rechteck 16">
+              <a:extLst>
+                <a:ext uri="{FF2B5EF4-FFF2-40B4-BE49-F238E27FC236}">
+                  <a16:creationId xmlns:a16="http://schemas.microsoft.com/office/drawing/2014/main" id="{221614E5-870B-4D5E-A43B-8FF7E5323484}"/>
+                </a:ext>
+                <a:ext uri="{C183D7F6-B498-43B3-948B-1728B52AA6E4}">
+                  <adec:decorative xmlns:adec="http://schemas.microsoft.com/office/drawing/2017/decorative" val="1"/>
+                </a:ext>
+              </a:extLst>
+            </p:cNvPr>
+            <p:cNvSpPr/>
+            <p:nvPr>
+              <p:extLst>
+                <p:ext uri="{386F3935-93C4-4BCD-93E2-E3B085C9AB24}">
+                  <p16:designElem xmlns:p16="http://schemas.microsoft.com/office/powerpoint/2015/main" val="1"/>
+                </p:ext>
+              </p:extLst>
+            </p:nvPr>
+          </p:nvSpPr>
+          <p:spPr>
+            <a:xfrm>
+              <a:off x="4241830" y="457200"/>
+              <a:ext cx="3703320" cy="91440"/>
+            </a:xfrm>
+            <a:prstGeom prst="rect">
+              <a:avLst/>
+            </a:prstGeom>
+            <a:solidFill>
+              <a:schemeClr val="accent2"/>
+            </a:solidFill>
+            <a:ln>
+              <a:noFill/>
+            </a:ln>
+            <a:effectLst/>
+          </p:spPr>
+          <p:style>
+            <a:lnRef idx="1">
+              <a:schemeClr val="accent1"/>
+            </a:lnRef>
+            <a:fillRef idx="3">
+              <a:schemeClr val="accent1"/>
+            </a:fillRef>
+            <a:effectRef idx="2">
+              <a:schemeClr val="accent1"/>
+            </a:effectRef>
+            <a:fontRef idx="minor">
+              <a:schemeClr val="lt1"/>
+            </a:fontRef>
+          </p:style>
+          <p:txBody>
+            <a:bodyPr/>
+            <a:lstStyle/>
+            <a:p>
+              <a:endParaRPr lang="de-AT"/>
+            </a:p>
+          </p:txBody>
+        </p:sp>
+      </p:grpSp>
+      <p:sp>
+        <p:nvSpPr>
+          <p:cNvPr id="6" name="Untertitel 5">
+            <a:extLst>
+              <a:ext uri="{FF2B5EF4-FFF2-40B4-BE49-F238E27FC236}">
+                <a16:creationId xmlns:a16="http://schemas.microsoft.com/office/drawing/2014/main" id="{08B07814-13F0-3D3F-89D0-F93230014320}"/>
+              </a:ext>
+            </a:extLst>
+          </p:cNvPr>
+          <p:cNvSpPr>
+            <a:spLocks noGrp="1"/>
+          </p:cNvSpPr>
+          <p:nvPr>
+            <p:ph type="subTitle" idx="1"/>
+          </p:nvPr>
+        </p:nvSpPr>
+        <p:spPr/>
+        <p:txBody>
+          <a:bodyPr/>
+          <a:lstStyle/>
+          <a:p>
+            <a:endParaRPr lang="de-AT"/>
+          </a:p>
+        </p:txBody>
+      </p:sp>
+    </p:spTree>
+    <p:extLst>
+      <p:ext uri="{BB962C8B-B14F-4D97-AF65-F5344CB8AC3E}">
+        <p14:creationId xmlns:p14="http://schemas.microsoft.com/office/powerpoint/2010/main" val="3501347425"/>
+      </p:ext>
+    </p:extLst>
+  </p:cSld>
+  <p:clrMapOvr>
+    <a:masterClrMapping/>
+  </p:clrMapOvr>
+</p:sld>
+</file>
+
+<file path=ppt/slides/slide11.xml><?xml version="1.0" encoding="utf-8"?>
+<p:sld xmlns:a="http://schemas.openxmlformats.org/drawingml/2006/main" xmlns:r="http://schemas.openxmlformats.org/officeDocument/2006/relationships" xmlns:p="http://schemas.openxmlformats.org/presentationml/2006/main">
+  <p:cSld>
+    <p:bg>
+      <p:bgPr>
+        <a:solidFill>
+          <a:schemeClr val="bg1"/>
+        </a:solidFill>
+        <a:effectLst/>
+      </p:bgPr>
+    </p:bg>
+    <p:spTree>
+      <p:nvGrpSpPr>
+        <p:cNvPr id="1" name="">
+          <a:extLst>
+            <a:ext uri="{FF2B5EF4-FFF2-40B4-BE49-F238E27FC236}">
+              <a16:creationId xmlns:a16="http://schemas.microsoft.com/office/drawing/2014/main" id="{03D61C0A-EA71-2EE4-9B19-22FD61B6D341}"/>
+            </a:ext>
+          </a:extLst>
+        </p:cNvPr>
+        <p:cNvGrpSpPr/>
+        <p:nvPr/>
+      </p:nvGrpSpPr>
+      <p:grpSpPr>
+        <a:xfrm>
+          <a:off x="0" y="0"/>
+          <a:ext cx="0" cy="0"/>
+          <a:chOff x="0" y="0"/>
+          <a:chExt cx="0" cy="0"/>
+        </a:xfrm>
+      </p:grpSpPr>
+      <p:sp>
+        <p:nvSpPr>
+          <p:cNvPr id="2" name="Titel 1">
+            <a:extLst>
+              <a:ext uri="{FF2B5EF4-FFF2-40B4-BE49-F238E27FC236}">
+                <a16:creationId xmlns:a16="http://schemas.microsoft.com/office/drawing/2014/main" id="{77F35C1F-972A-C941-35DE-AF62475894C6}"/>
+              </a:ext>
+            </a:extLst>
+          </p:cNvPr>
+          <p:cNvSpPr>
+            <a:spLocks noGrp="1"/>
+          </p:cNvSpPr>
+          <p:nvPr>
+            <p:ph type="title"/>
+          </p:nvPr>
+        </p:nvSpPr>
+        <p:spPr/>
+        <p:txBody>
+          <a:bodyPr rtlCol="0"/>
+          <a:lstStyle/>
+          <a:p>
+            <a:pPr rtl="0"/>
+            <a:r>
+              <a:rPr lang="de-DE" dirty="0"/>
+              <a:t>Interpretation der Ergebnisse</a:t>
+            </a:r>
+          </a:p>
+        </p:txBody>
+      </p:sp>
+      <p:sp>
+        <p:nvSpPr>
+          <p:cNvPr id="6" name="Inhaltsplatzhalter 5">
+            <a:extLst>
+              <a:ext uri="{FF2B5EF4-FFF2-40B4-BE49-F238E27FC236}">
+                <a16:creationId xmlns:a16="http://schemas.microsoft.com/office/drawing/2014/main" id="{AEBB9406-CC1C-8F1C-DA12-7C6E38358CBB}"/>
+              </a:ext>
+            </a:extLst>
+          </p:cNvPr>
+          <p:cNvSpPr>
+            <a:spLocks noGrp="1"/>
+          </p:cNvSpPr>
+          <p:nvPr>
+            <p:ph sz="half" idx="2"/>
+          </p:nvPr>
+        </p:nvSpPr>
+        <p:spPr>
+          <a:xfrm>
+            <a:off x="581193" y="2228003"/>
+            <a:ext cx="11029616" cy="3633047"/>
+          </a:xfrm>
+        </p:spPr>
+        <p:txBody>
+          <a:bodyPr/>
+          <a:lstStyle/>
+          <a:p>
+            <a:r>
+              <a:rPr lang="de-AT" dirty="0" err="1"/>
+              <a:t>test</a:t>
+            </a:r>
+            <a:endParaRPr lang="de-AT" dirty="0"/>
+          </a:p>
+        </p:txBody>
+      </p:sp>
+    </p:spTree>
+    <p:extLst>
+      <p:ext uri="{BB962C8B-B14F-4D97-AF65-F5344CB8AC3E}">
+        <p14:creationId xmlns:p14="http://schemas.microsoft.com/office/powerpoint/2010/main" val="1747102689"/>
+      </p:ext>
+    </p:extLst>
+  </p:cSld>
+  <p:clrMapOvr>
+    <a:masterClrMapping/>
+  </p:clrMapOvr>
+</p:sld>
+</file>
+
 <file path=ppt/slides/slide2.xml><?xml version="1.0" encoding="utf-8"?>
 <p:sld xmlns:a="http://schemas.openxmlformats.org/drawingml/2006/main" xmlns:r="http://schemas.openxmlformats.org/officeDocument/2006/relationships" xmlns:p="http://schemas.openxmlformats.org/presentationml/2006/main">
   <p:cSld>
@@ -10994,7 +11993,13 @@
     </p:bg>
     <p:spTree>
       <p:nvGrpSpPr>
-        <p:cNvPr id="1" name=""/>
+        <p:cNvPr id="1" name="">
+          <a:extLst>
+            <a:ext uri="{FF2B5EF4-FFF2-40B4-BE49-F238E27FC236}">
+              <a16:creationId xmlns:a16="http://schemas.microsoft.com/office/drawing/2014/main" id="{39C6224C-8A6A-3C4A-DFF0-5B19FBF435A2}"/>
+            </a:ext>
+          </a:extLst>
+        </p:cNvPr>
         <p:cNvGrpSpPr/>
         <p:nvPr/>
       </p:nvGrpSpPr>
@@ -11006,9 +12011,253 @@
           <a:chExt cx="0" cy="0"/>
         </a:xfrm>
       </p:grpSpPr>
+      <p:sp>
+        <p:nvSpPr>
+          <p:cNvPr id="12" name="Rectangle 11">
+            <a:extLst>
+              <a:ext uri="{FF2B5EF4-FFF2-40B4-BE49-F238E27FC236}">
+                <a16:creationId xmlns:a16="http://schemas.microsoft.com/office/drawing/2014/main" id="{A078A52F-85EA-4C0B-962B-D9D9DD4DD78C}"/>
+              </a:ext>
+              <a:ext uri="{C183D7F6-B498-43B3-948B-1728B52AA6E4}">
+                <adec:decorative xmlns:adec="http://schemas.microsoft.com/office/drawing/2017/decorative" val="1"/>
+              </a:ext>
+            </a:extLst>
+          </p:cNvPr>
+          <p:cNvSpPr>
+            <a:spLocks noGrp="1" noRot="1" noChangeAspect="1" noMove="1" noResize="1" noEditPoints="1" noAdjustHandles="1" noChangeArrowheads="1" noChangeShapeType="1" noTextEdit="1"/>
+          </p:cNvSpPr>
+          <p:nvPr>
+            <p:extLst>
+              <p:ext uri="{386F3935-93C4-4BCD-93E2-E3B085C9AB24}">
+                <p16:designElem xmlns:p16="http://schemas.microsoft.com/office/powerpoint/2015/main" val="1"/>
+              </p:ext>
+            </p:extLst>
+          </p:nvPr>
+        </p:nvSpPr>
+        <p:spPr>
+          <a:xfrm>
+            <a:off x="446534" y="457200"/>
+            <a:ext cx="3703320" cy="94997"/>
+          </a:xfrm>
+          <a:prstGeom prst="rect">
+            <a:avLst/>
+          </a:prstGeom>
+          <a:solidFill>
+            <a:schemeClr val="accent1"/>
+          </a:solidFill>
+          <a:ln>
+            <a:noFill/>
+          </a:ln>
+          <a:effectLst/>
+        </p:spPr>
+        <p:style>
+          <a:lnRef idx="1">
+            <a:schemeClr val="accent1"/>
+          </a:lnRef>
+          <a:fillRef idx="3">
+            <a:schemeClr val="accent1"/>
+          </a:fillRef>
+          <a:effectRef idx="2">
+            <a:schemeClr val="accent1"/>
+          </a:effectRef>
+          <a:fontRef idx="minor">
+            <a:schemeClr val="lt1"/>
+          </a:fontRef>
+        </p:style>
+        <p:txBody>
+          <a:bodyPr/>
+          <a:lstStyle/>
+          <a:p>
+            <a:endParaRPr lang="de-AT"/>
+          </a:p>
+        </p:txBody>
+      </p:sp>
+      <p:sp>
+        <p:nvSpPr>
+          <p:cNvPr id="14" name="Rectangle 13">
+            <a:extLst>
+              <a:ext uri="{FF2B5EF4-FFF2-40B4-BE49-F238E27FC236}">
+                <a16:creationId xmlns:a16="http://schemas.microsoft.com/office/drawing/2014/main" id="{919797D5-5700-4683-B30A-5B4D56CB8270}"/>
+              </a:ext>
+              <a:ext uri="{C183D7F6-B498-43B3-948B-1728B52AA6E4}">
+                <adec:decorative xmlns:adec="http://schemas.microsoft.com/office/drawing/2017/decorative" val="1"/>
+              </a:ext>
+            </a:extLst>
+          </p:cNvPr>
+          <p:cNvSpPr>
+            <a:spLocks noGrp="1" noRot="1" noChangeAspect="1" noMove="1" noResize="1" noEditPoints="1" noAdjustHandles="1" noChangeArrowheads="1" noChangeShapeType="1" noTextEdit="1"/>
+          </p:cNvSpPr>
+          <p:nvPr>
+            <p:extLst>
+              <p:ext uri="{386F3935-93C4-4BCD-93E2-E3B085C9AB24}">
+                <p16:designElem xmlns:p16="http://schemas.microsoft.com/office/powerpoint/2015/main" val="1"/>
+              </p:ext>
+            </p:extLst>
+          </p:nvPr>
+        </p:nvSpPr>
+        <p:spPr>
+          <a:xfrm>
+            <a:off x="8042147" y="453643"/>
+            <a:ext cx="3703320" cy="98554"/>
+          </a:xfrm>
+          <a:prstGeom prst="rect">
+            <a:avLst/>
+          </a:prstGeom>
+          <a:solidFill>
+            <a:schemeClr val="accent4"/>
+          </a:solidFill>
+          <a:ln>
+            <a:noFill/>
+          </a:ln>
+          <a:effectLst/>
+        </p:spPr>
+        <p:style>
+          <a:lnRef idx="1">
+            <a:schemeClr val="accent1"/>
+          </a:lnRef>
+          <a:fillRef idx="3">
+            <a:schemeClr val="accent1"/>
+          </a:fillRef>
+          <a:effectRef idx="2">
+            <a:schemeClr val="accent1"/>
+          </a:effectRef>
+          <a:fontRef idx="minor">
+            <a:schemeClr val="lt1"/>
+          </a:fontRef>
+        </p:style>
+        <p:txBody>
+          <a:bodyPr/>
+          <a:lstStyle/>
+          <a:p>
+            <a:endParaRPr lang="de-AT"/>
+          </a:p>
+        </p:txBody>
+      </p:sp>
+      <p:sp>
+        <p:nvSpPr>
+          <p:cNvPr id="16" name="Rectangle 15">
+            <a:extLst>
+              <a:ext uri="{FF2B5EF4-FFF2-40B4-BE49-F238E27FC236}">
+                <a16:creationId xmlns:a16="http://schemas.microsoft.com/office/drawing/2014/main" id="{4856A7B9-9801-42EC-A4C9-7E22A56EF53D}"/>
+              </a:ext>
+              <a:ext uri="{C183D7F6-B498-43B3-948B-1728B52AA6E4}">
+                <adec:decorative xmlns:adec="http://schemas.microsoft.com/office/drawing/2017/decorative" val="1"/>
+              </a:ext>
+            </a:extLst>
+          </p:cNvPr>
+          <p:cNvSpPr>
+            <a:spLocks noGrp="1" noRot="1" noChangeAspect="1" noMove="1" noResize="1" noEditPoints="1" noAdjustHandles="1" noChangeArrowheads="1" noChangeShapeType="1" noTextEdit="1"/>
+          </p:cNvSpPr>
+          <p:nvPr>
+            <p:extLst>
+              <p:ext uri="{386F3935-93C4-4BCD-93E2-E3B085C9AB24}">
+                <p16:designElem xmlns:p16="http://schemas.microsoft.com/office/powerpoint/2015/main" val="1"/>
+              </p:ext>
+            </p:extLst>
+          </p:nvPr>
+        </p:nvSpPr>
+        <p:spPr>
+          <a:xfrm>
+            <a:off x="4241830" y="457200"/>
+            <a:ext cx="3703320" cy="91440"/>
+          </a:xfrm>
+          <a:prstGeom prst="rect">
+            <a:avLst/>
+          </a:prstGeom>
+          <a:solidFill>
+            <a:schemeClr val="accent2"/>
+          </a:solidFill>
+          <a:ln>
+            <a:noFill/>
+          </a:ln>
+          <a:effectLst/>
+        </p:spPr>
+        <p:style>
+          <a:lnRef idx="1">
+            <a:schemeClr val="accent1"/>
+          </a:lnRef>
+          <a:fillRef idx="3">
+            <a:schemeClr val="accent1"/>
+          </a:fillRef>
+          <a:effectRef idx="2">
+            <a:schemeClr val="accent1"/>
+          </a:effectRef>
+          <a:fontRef idx="minor">
+            <a:schemeClr val="lt1"/>
+          </a:fontRef>
+        </p:style>
+        <p:txBody>
+          <a:bodyPr/>
+          <a:lstStyle/>
+          <a:p>
+            <a:endParaRPr lang="de-AT"/>
+          </a:p>
+        </p:txBody>
+      </p:sp>
+      <p:sp>
+        <p:nvSpPr>
+          <p:cNvPr id="18" name="Rectangle 17">
+            <a:extLst>
+              <a:ext uri="{FF2B5EF4-FFF2-40B4-BE49-F238E27FC236}">
+                <a16:creationId xmlns:a16="http://schemas.microsoft.com/office/drawing/2014/main" id="{8AD54DB8-C150-4290-85D6-F5B0262BFEEF}"/>
+              </a:ext>
+              <a:ext uri="{C183D7F6-B498-43B3-948B-1728B52AA6E4}">
+                <adec:decorative xmlns:adec="http://schemas.microsoft.com/office/drawing/2017/decorative" val="1"/>
+              </a:ext>
+            </a:extLst>
+          </p:cNvPr>
+          <p:cNvSpPr>
+            <a:spLocks noGrp="1" noRot="1" noChangeAspect="1" noMove="1" noResize="1" noEditPoints="1" noAdjustHandles="1" noChangeArrowheads="1" noChangeShapeType="1" noTextEdit="1"/>
+          </p:cNvSpPr>
+          <p:nvPr>
+            <p:extLst>
+              <p:ext uri="{386F3935-93C4-4BCD-93E2-E3B085C9AB24}">
+                <p16:designElem xmlns:p16="http://schemas.microsoft.com/office/powerpoint/2015/main" val="1"/>
+              </p:ext>
+            </p:extLst>
+          </p:nvPr>
+        </p:nvSpPr>
+        <p:spPr>
+          <a:xfrm>
+            <a:off x="446534" y="3085765"/>
+            <a:ext cx="11262866" cy="3304800"/>
+          </a:xfrm>
+          <a:prstGeom prst="rect">
+            <a:avLst/>
+          </a:prstGeom>
+          <a:solidFill>
+            <a:schemeClr val="accent1"/>
+          </a:solidFill>
+          <a:ln>
+            <a:noFill/>
+          </a:ln>
+          <a:effectLst/>
+        </p:spPr>
+        <p:style>
+          <a:lnRef idx="1">
+            <a:schemeClr val="accent1"/>
+          </a:lnRef>
+          <a:fillRef idx="3">
+            <a:schemeClr val="accent1"/>
+          </a:fillRef>
+          <a:effectRef idx="2">
+            <a:schemeClr val="accent1"/>
+          </a:effectRef>
+          <a:fontRef idx="minor">
+            <a:schemeClr val="lt1"/>
+          </a:fontRef>
+        </p:style>
+        <p:txBody>
+          <a:bodyPr/>
+          <a:lstStyle/>
+          <a:p>
+            <a:endParaRPr lang="de-AT"/>
+          </a:p>
+        </p:txBody>
+      </p:sp>
       <p:sp useBgFill="1">
         <p:nvSpPr>
-          <p:cNvPr id="10" name="Rechteck 9">
+          <p:cNvPr id="20" name="Rectangle 19">
             <a:extLst>
               <a:ext uri="{FF2B5EF4-FFF2-40B4-BE49-F238E27FC236}">
                 <a16:creationId xmlns:a16="http://schemas.microsoft.com/office/drawing/2014/main" id="{379F11E2-8BA5-4C5C-AE7C-361E5EA011FF}"/>
@@ -11061,35 +12310,33 @@
           <a:bodyPr rtlCol="0" anchor="ctr"/>
           <a:lstStyle/>
           <a:p>
-            <a:pPr algn="ctr" rtl="0"/>
-            <a:endParaRPr lang="de-DE"/>
+            <a:pPr algn="ctr"/>
+            <a:endParaRPr lang="en-US"/>
           </a:p>
         </p:txBody>
       </p:sp>
       <p:pic>
         <p:nvPicPr>
-          <p:cNvPr id="5" name="Bild 4" descr="Digitale Zahlen">
+          <p:cNvPr id="7" name="Inhaltsplatzhalter 6">
             <a:extLst>
               <a:ext uri="{FF2B5EF4-FFF2-40B4-BE49-F238E27FC236}">
-                <a16:creationId xmlns:a16="http://schemas.microsoft.com/office/drawing/2014/main" id="{A21EA617-6D48-425F-97A8-7FEC82C8F401}"/>
+                <a16:creationId xmlns:a16="http://schemas.microsoft.com/office/drawing/2014/main" id="{2C21C568-C9B8-4D3B-E123-497C2DB3DB86}"/>
               </a:ext>
             </a:extLst>
           </p:cNvPr>
           <p:cNvPicPr>
-            <a:picLocks noChangeAspect="1"/>
+            <a:picLocks noGrp="1" noChangeAspect="1"/>
           </p:cNvPicPr>
-          <p:nvPr/>
+          <p:nvPr>
+            <p:ph sz="half" idx="2"/>
+          </p:nvPr>
         </p:nvPicPr>
-        <p:blipFill rotWithShape="1">
-          <a:blip r:embed="rId3" cstate="screen">
-            <a:extLst>
-              <a:ext uri="{28A0092B-C50C-407E-A947-70E740481C1C}">
-                <a14:useLocalDpi xmlns:a14="http://schemas.microsoft.com/office/drawing/2010/main"/>
-              </a:ext>
-            </a:extLst>
-          </a:blip>
-          <a:srcRect l="2189" r="9642" b="1"/>
-          <a:stretch/>
+        <p:blipFill>
+          <a:blip r:embed="rId3"/>
+          <a:srcRect r="3903" b="-1"/>
+          <a:stretch>
+            <a:fillRect/>
+          </a:stretch>
         </p:blipFill>
         <p:spPr>
           <a:xfrm>
@@ -11103,7 +12350,7 @@
       </p:pic>
       <p:sp>
         <p:nvSpPr>
-          <p:cNvPr id="12" name="Rechteck 11">
+          <p:cNvPr id="22" name="Rectangle 21">
             <a:extLst>
               <a:ext uri="{FF2B5EF4-FFF2-40B4-BE49-F238E27FC236}">
                 <a16:creationId xmlns:a16="http://schemas.microsoft.com/office/drawing/2014/main" id="{7C00E1DA-EC7C-40FC-95E3-11FDCD2E4291}"/>
@@ -11167,7 +12414,7 @@
           <p:cNvPr id="2" name="Titel 1">
             <a:extLst>
               <a:ext uri="{FF2B5EF4-FFF2-40B4-BE49-F238E27FC236}">
-                <a16:creationId xmlns:a16="http://schemas.microsoft.com/office/drawing/2014/main" id="{0F87E73C-2B1A-4602-BFBE-CFE1E55D9B38}"/>
+                <a16:creationId xmlns:a16="http://schemas.microsoft.com/office/drawing/2014/main" id="{0A36710B-EE68-FFF0-09F8-08322FE3CD3C}"/>
               </a:ext>
             </a:extLst>
           </p:cNvPr>
@@ -11175,36 +12422,35 @@
             <a:spLocks noGrp="1"/>
           </p:cNvSpPr>
           <p:nvPr>
-            <p:ph type="ctrTitle"/>
+            <p:ph type="title"/>
           </p:nvPr>
         </p:nvSpPr>
         <p:spPr>
           <a:xfrm>
-            <a:off x="8296275" y="1419226"/>
-            <a:ext cx="3081576" cy="1746762"/>
+            <a:off x="8296275" y="1419225"/>
+            <a:ext cx="3081576" cy="2085869"/>
           </a:xfrm>
         </p:spPr>
         <p:txBody>
-          <a:bodyPr rtlCol="0">
+          <a:bodyPr vert="horz" lIns="91440" tIns="45720" rIns="91440" bIns="45720" rtlCol="0" anchor="b">
             <a:normAutofit/>
           </a:bodyPr>
           <a:lstStyle/>
           <a:p>
-            <a:pPr rtl="0"/>
             <a:r>
-              <a:rPr lang="de-DE" dirty="0">
+              <a:rPr lang="en-US" sz="3600">
                 <a:solidFill>
                   <a:srgbClr val="FFFFFF"/>
                 </a:solidFill>
               </a:rPr>
-              <a:t>Demo</a:t>
+              <a:t>Q_i</a:t>
             </a:r>
           </a:p>
         </p:txBody>
       </p:sp>
       <p:grpSp>
         <p:nvGrpSpPr>
-          <p:cNvPr id="14" name="Gruppe 13">
+          <p:cNvPr id="24" name="Group 23">
             <a:extLst>
               <a:ext uri="{FF2B5EF4-FFF2-40B4-BE49-F238E27FC236}">
                 <a16:creationId xmlns:a16="http://schemas.microsoft.com/office/drawing/2014/main" id="{9A421166-2996-41A7-B094-AE5316F347DD}"/>
@@ -11235,7 +12481,7 @@
         </p:grpSpPr>
         <p:sp>
           <p:nvSpPr>
-            <p:cNvPr id="15" name="Rechteck 14">
+            <p:cNvPr id="25" name="Rectangle 24">
               <a:extLst>
                 <a:ext uri="{FF2B5EF4-FFF2-40B4-BE49-F238E27FC236}">
                   <a16:creationId xmlns:a16="http://schemas.microsoft.com/office/drawing/2014/main" id="{FDBB1B92-A3EB-43E4-8FAB-D20E8ED14CEF}"/>
@@ -11294,7 +12540,7 @@
         </p:sp>
         <p:sp>
           <p:nvSpPr>
-            <p:cNvPr id="16" name="Rechteck 15">
+            <p:cNvPr id="26" name="Rectangle 25">
               <a:extLst>
                 <a:ext uri="{FF2B5EF4-FFF2-40B4-BE49-F238E27FC236}">
                   <a16:creationId xmlns:a16="http://schemas.microsoft.com/office/drawing/2014/main" id="{3F3972F4-FE7E-48EA-AAD8-9BE5750A6672}"/>
@@ -11353,7 +12599,7 @@
         </p:sp>
         <p:sp>
           <p:nvSpPr>
-            <p:cNvPr id="17" name="Rechteck 16">
+            <p:cNvPr id="27" name="Rectangle 26">
               <a:extLst>
                 <a:ext uri="{FF2B5EF4-FFF2-40B4-BE49-F238E27FC236}">
                   <a16:creationId xmlns:a16="http://schemas.microsoft.com/office/drawing/2014/main" id="{221614E5-870B-4D5E-A43B-8FF7E5323484}"/>
@@ -11411,35 +12657,10 @@
           </p:txBody>
         </p:sp>
       </p:grpSp>
-      <p:sp>
-        <p:nvSpPr>
-          <p:cNvPr id="6" name="Untertitel 5">
-            <a:extLst>
-              <a:ext uri="{FF2B5EF4-FFF2-40B4-BE49-F238E27FC236}">
-                <a16:creationId xmlns:a16="http://schemas.microsoft.com/office/drawing/2014/main" id="{08B07814-13F0-3D3F-89D0-F93230014320}"/>
-              </a:ext>
-            </a:extLst>
-          </p:cNvPr>
-          <p:cNvSpPr>
-            <a:spLocks noGrp="1"/>
-          </p:cNvSpPr>
-          <p:nvPr>
-            <p:ph type="subTitle" idx="1"/>
-          </p:nvPr>
-        </p:nvSpPr>
-        <p:spPr/>
-        <p:txBody>
-          <a:bodyPr/>
-          <a:lstStyle/>
-          <a:p>
-            <a:endParaRPr lang="de-AT"/>
-          </a:p>
-        </p:txBody>
-      </p:sp>
     </p:spTree>
     <p:extLst>
       <p:ext uri="{BB962C8B-B14F-4D97-AF65-F5344CB8AC3E}">
-        <p14:creationId xmlns:p14="http://schemas.microsoft.com/office/powerpoint/2010/main" val="3501347425"/>
+        <p14:creationId xmlns:p14="http://schemas.microsoft.com/office/powerpoint/2010/main" val="567447768"/>
       </p:ext>
     </p:extLst>
   </p:cSld>
@@ -11465,7 +12686,7 @@
         <p:cNvPr id="1" name="">
           <a:extLst>
             <a:ext uri="{FF2B5EF4-FFF2-40B4-BE49-F238E27FC236}">
-              <a16:creationId xmlns:a16="http://schemas.microsoft.com/office/drawing/2014/main" id="{03D61C0A-EA71-2EE4-9B19-22FD61B6D341}"/>
+              <a16:creationId xmlns:a16="http://schemas.microsoft.com/office/drawing/2014/main" id="{A3D700A5-B629-3493-6A88-9674D77C202C}"/>
             </a:ext>
           </a:extLst>
         </p:cNvPr>
@@ -11482,10 +12703,371 @@
       </p:grpSpPr>
       <p:sp>
         <p:nvSpPr>
+          <p:cNvPr id="32" name="Rectangle 31">
+            <a:extLst>
+              <a:ext uri="{FF2B5EF4-FFF2-40B4-BE49-F238E27FC236}">
+                <a16:creationId xmlns:a16="http://schemas.microsoft.com/office/drawing/2014/main" id="{A078A52F-85EA-4C0B-962B-D9D9DD4DD78C}"/>
+              </a:ext>
+              <a:ext uri="{C183D7F6-B498-43B3-948B-1728B52AA6E4}">
+                <adec:decorative xmlns:adec="http://schemas.microsoft.com/office/drawing/2017/decorative" val="1"/>
+              </a:ext>
+            </a:extLst>
+          </p:cNvPr>
+          <p:cNvSpPr>
+            <a:spLocks noGrp="1" noRot="1" noChangeAspect="1" noMove="1" noResize="1" noEditPoints="1" noAdjustHandles="1" noChangeArrowheads="1" noChangeShapeType="1" noTextEdit="1"/>
+          </p:cNvSpPr>
+          <p:nvPr>
+            <p:extLst>
+              <p:ext uri="{386F3935-93C4-4BCD-93E2-E3B085C9AB24}">
+                <p16:designElem xmlns:p16="http://schemas.microsoft.com/office/powerpoint/2015/main" val="1"/>
+              </p:ext>
+            </p:extLst>
+          </p:nvPr>
+        </p:nvSpPr>
+        <p:spPr>
+          <a:xfrm>
+            <a:off x="446534" y="457200"/>
+            <a:ext cx="3703320" cy="94997"/>
+          </a:xfrm>
+          <a:prstGeom prst="rect">
+            <a:avLst/>
+          </a:prstGeom>
+          <a:solidFill>
+            <a:schemeClr val="accent1"/>
+          </a:solidFill>
+          <a:ln>
+            <a:noFill/>
+          </a:ln>
+          <a:effectLst/>
+        </p:spPr>
+        <p:style>
+          <a:lnRef idx="1">
+            <a:schemeClr val="accent1"/>
+          </a:lnRef>
+          <a:fillRef idx="3">
+            <a:schemeClr val="accent1"/>
+          </a:fillRef>
+          <a:effectRef idx="2">
+            <a:schemeClr val="accent1"/>
+          </a:effectRef>
+          <a:fontRef idx="minor">
+            <a:schemeClr val="lt1"/>
+          </a:fontRef>
+        </p:style>
+      </p:sp>
+      <p:sp>
+        <p:nvSpPr>
+          <p:cNvPr id="34" name="Rectangle 33">
+            <a:extLst>
+              <a:ext uri="{FF2B5EF4-FFF2-40B4-BE49-F238E27FC236}">
+                <a16:creationId xmlns:a16="http://schemas.microsoft.com/office/drawing/2014/main" id="{919797D5-5700-4683-B30A-5B4D56CB8270}"/>
+              </a:ext>
+              <a:ext uri="{C183D7F6-B498-43B3-948B-1728B52AA6E4}">
+                <adec:decorative xmlns:adec="http://schemas.microsoft.com/office/drawing/2017/decorative" val="1"/>
+              </a:ext>
+            </a:extLst>
+          </p:cNvPr>
+          <p:cNvSpPr>
+            <a:spLocks noGrp="1" noRot="1" noChangeAspect="1" noMove="1" noResize="1" noEditPoints="1" noAdjustHandles="1" noChangeArrowheads="1" noChangeShapeType="1" noTextEdit="1"/>
+          </p:cNvSpPr>
+          <p:nvPr>
+            <p:extLst>
+              <p:ext uri="{386F3935-93C4-4BCD-93E2-E3B085C9AB24}">
+                <p16:designElem xmlns:p16="http://schemas.microsoft.com/office/powerpoint/2015/main" val="1"/>
+              </p:ext>
+            </p:extLst>
+          </p:nvPr>
+        </p:nvSpPr>
+        <p:spPr>
+          <a:xfrm>
+            <a:off x="8042147" y="453643"/>
+            <a:ext cx="3703320" cy="98554"/>
+          </a:xfrm>
+          <a:prstGeom prst="rect">
+            <a:avLst/>
+          </a:prstGeom>
+          <a:solidFill>
+            <a:schemeClr val="accent4"/>
+          </a:solidFill>
+          <a:ln>
+            <a:noFill/>
+          </a:ln>
+          <a:effectLst/>
+        </p:spPr>
+        <p:style>
+          <a:lnRef idx="1">
+            <a:schemeClr val="accent1"/>
+          </a:lnRef>
+          <a:fillRef idx="3">
+            <a:schemeClr val="accent1"/>
+          </a:fillRef>
+          <a:effectRef idx="2">
+            <a:schemeClr val="accent1"/>
+          </a:effectRef>
+          <a:fontRef idx="minor">
+            <a:schemeClr val="lt1"/>
+          </a:fontRef>
+        </p:style>
+      </p:sp>
+      <p:sp>
+        <p:nvSpPr>
+          <p:cNvPr id="36" name="Rectangle 35">
+            <a:extLst>
+              <a:ext uri="{FF2B5EF4-FFF2-40B4-BE49-F238E27FC236}">
+                <a16:creationId xmlns:a16="http://schemas.microsoft.com/office/drawing/2014/main" id="{4856A7B9-9801-42EC-A4C9-7E22A56EF53D}"/>
+              </a:ext>
+              <a:ext uri="{C183D7F6-B498-43B3-948B-1728B52AA6E4}">
+                <adec:decorative xmlns:adec="http://schemas.microsoft.com/office/drawing/2017/decorative" val="1"/>
+              </a:ext>
+            </a:extLst>
+          </p:cNvPr>
+          <p:cNvSpPr>
+            <a:spLocks noGrp="1" noRot="1" noChangeAspect="1" noMove="1" noResize="1" noEditPoints="1" noAdjustHandles="1" noChangeArrowheads="1" noChangeShapeType="1" noTextEdit="1"/>
+          </p:cNvSpPr>
+          <p:nvPr>
+            <p:extLst>
+              <p:ext uri="{386F3935-93C4-4BCD-93E2-E3B085C9AB24}">
+                <p16:designElem xmlns:p16="http://schemas.microsoft.com/office/powerpoint/2015/main" val="1"/>
+              </p:ext>
+            </p:extLst>
+          </p:nvPr>
+        </p:nvSpPr>
+        <p:spPr>
+          <a:xfrm>
+            <a:off x="4241830" y="457200"/>
+            <a:ext cx="3703320" cy="91440"/>
+          </a:xfrm>
+          <a:prstGeom prst="rect">
+            <a:avLst/>
+          </a:prstGeom>
+          <a:solidFill>
+            <a:schemeClr val="accent2"/>
+          </a:solidFill>
+          <a:ln>
+            <a:noFill/>
+          </a:ln>
+          <a:effectLst/>
+        </p:spPr>
+        <p:style>
+          <a:lnRef idx="1">
+            <a:schemeClr val="accent1"/>
+          </a:lnRef>
+          <a:fillRef idx="3">
+            <a:schemeClr val="accent1"/>
+          </a:fillRef>
+          <a:effectRef idx="2">
+            <a:schemeClr val="accent1"/>
+          </a:effectRef>
+          <a:fontRef idx="minor">
+            <a:schemeClr val="lt1"/>
+          </a:fontRef>
+        </p:style>
+      </p:sp>
+      <p:sp>
+        <p:nvSpPr>
+          <p:cNvPr id="38" name="Rectangle 37">
+            <a:extLst>
+              <a:ext uri="{FF2B5EF4-FFF2-40B4-BE49-F238E27FC236}">
+                <a16:creationId xmlns:a16="http://schemas.microsoft.com/office/drawing/2014/main" id="{8AD54DB8-C150-4290-85D6-F5B0262BFEEF}"/>
+              </a:ext>
+              <a:ext uri="{C183D7F6-B498-43B3-948B-1728B52AA6E4}">
+                <adec:decorative xmlns:adec="http://schemas.microsoft.com/office/drawing/2017/decorative" val="1"/>
+              </a:ext>
+            </a:extLst>
+          </p:cNvPr>
+          <p:cNvSpPr>
+            <a:spLocks noGrp="1" noRot="1" noChangeAspect="1" noMove="1" noResize="1" noEditPoints="1" noAdjustHandles="1" noChangeArrowheads="1" noChangeShapeType="1" noTextEdit="1"/>
+          </p:cNvSpPr>
+          <p:nvPr>
+            <p:extLst>
+              <p:ext uri="{386F3935-93C4-4BCD-93E2-E3B085C9AB24}">
+                <p16:designElem xmlns:p16="http://schemas.microsoft.com/office/powerpoint/2015/main" val="1"/>
+              </p:ext>
+            </p:extLst>
+          </p:nvPr>
+        </p:nvSpPr>
+        <p:spPr>
+          <a:xfrm>
+            <a:off x="446534" y="3085765"/>
+            <a:ext cx="11262866" cy="3304800"/>
+          </a:xfrm>
+          <a:prstGeom prst="rect">
+            <a:avLst/>
+          </a:prstGeom>
+          <a:solidFill>
+            <a:schemeClr val="accent1"/>
+          </a:solidFill>
+          <a:ln>
+            <a:noFill/>
+          </a:ln>
+          <a:effectLst/>
+        </p:spPr>
+        <p:style>
+          <a:lnRef idx="1">
+            <a:schemeClr val="accent1"/>
+          </a:lnRef>
+          <a:fillRef idx="3">
+            <a:schemeClr val="accent1"/>
+          </a:fillRef>
+          <a:effectRef idx="2">
+            <a:schemeClr val="accent1"/>
+          </a:effectRef>
+          <a:fontRef idx="minor">
+            <a:schemeClr val="lt1"/>
+          </a:fontRef>
+        </p:style>
+      </p:sp>
+      <p:sp useBgFill="1">
+        <p:nvSpPr>
+          <p:cNvPr id="40" name="Rectangle 39">
+            <a:extLst>
+              <a:ext uri="{FF2B5EF4-FFF2-40B4-BE49-F238E27FC236}">
+                <a16:creationId xmlns:a16="http://schemas.microsoft.com/office/drawing/2014/main" id="{379F11E2-8BA5-4C5C-AE7C-361E5EA011FF}"/>
+              </a:ext>
+              <a:ext uri="{C183D7F6-B498-43B3-948B-1728B52AA6E4}">
+                <adec:decorative xmlns:adec="http://schemas.microsoft.com/office/drawing/2017/decorative" val="1"/>
+              </a:ext>
+            </a:extLst>
+          </p:cNvPr>
+          <p:cNvSpPr>
+            <a:spLocks noGrp="1" noRot="1" noChangeAspect="1" noMove="1" noResize="1" noEditPoints="1" noAdjustHandles="1" noChangeArrowheads="1" noChangeShapeType="1" noTextEdit="1"/>
+          </p:cNvSpPr>
+          <p:nvPr>
+            <p:extLst>
+              <p:ext uri="{386F3935-93C4-4BCD-93E2-E3B085C9AB24}">
+                <p16:designElem xmlns:p16="http://schemas.microsoft.com/office/powerpoint/2015/main" val="1"/>
+              </p:ext>
+            </p:extLst>
+          </p:nvPr>
+        </p:nvSpPr>
+        <p:spPr>
+          <a:xfrm>
+            <a:off x="0" y="1"/>
+            <a:ext cx="12191999" cy="6858000"/>
+          </a:xfrm>
+          <a:prstGeom prst="rect">
+            <a:avLst/>
+          </a:prstGeom>
+          <a:ln>
+            <a:noFill/>
+          </a:ln>
+        </p:spPr>
+        <p:style>
+          <a:lnRef idx="2">
+            <a:schemeClr val="accent1">
+              <a:shade val="50000"/>
+            </a:schemeClr>
+          </a:lnRef>
+          <a:fillRef idx="1">
+            <a:schemeClr val="accent1"/>
+          </a:fillRef>
+          <a:effectRef idx="0">
+            <a:schemeClr val="accent1"/>
+          </a:effectRef>
+          <a:fontRef idx="minor">
+            <a:schemeClr val="lt1"/>
+          </a:fontRef>
+        </p:style>
+        <p:txBody>
+          <a:bodyPr rtlCol="0" anchor="ctr"/>
+          <a:lstStyle/>
+          <a:p>
+            <a:pPr algn="ctr"/>
+            <a:endParaRPr lang="en-US"/>
+          </a:p>
+        </p:txBody>
+      </p:sp>
+      <p:pic>
+        <p:nvPicPr>
+          <p:cNvPr id="6" name="Grafik 5">
+            <a:extLst>
+              <a:ext uri="{FF2B5EF4-FFF2-40B4-BE49-F238E27FC236}">
+                <a16:creationId xmlns:a16="http://schemas.microsoft.com/office/drawing/2014/main" id="{72EA7E18-3D88-A852-0D32-2BF964766F48}"/>
+              </a:ext>
+            </a:extLst>
+          </p:cNvPr>
+          <p:cNvPicPr>
+            <a:picLocks noChangeAspect="1"/>
+          </p:cNvPicPr>
+          <p:nvPr/>
+        </p:nvPicPr>
+        <p:blipFill>
+          <a:blip r:embed="rId3"/>
+          <a:srcRect t="4576" r="2" b="1672"/>
+          <a:stretch>
+            <a:fillRect/>
+          </a:stretch>
+        </p:blipFill>
+        <p:spPr>
+          <a:xfrm>
+            <a:off x="446534" y="723899"/>
+            <a:ext cx="7498616" cy="5676901"/>
+          </a:xfrm>
+          <a:prstGeom prst="rect">
+            <a:avLst/>
+          </a:prstGeom>
+        </p:spPr>
+      </p:pic>
+      <p:sp>
+        <p:nvSpPr>
+          <p:cNvPr id="42" name="Rectangle 41">
+            <a:extLst>
+              <a:ext uri="{FF2B5EF4-FFF2-40B4-BE49-F238E27FC236}">
+                <a16:creationId xmlns:a16="http://schemas.microsoft.com/office/drawing/2014/main" id="{7C00E1DA-EC7C-40FC-95E3-11FDCD2E4291}"/>
+              </a:ext>
+              <a:ext uri="{C183D7F6-B498-43B3-948B-1728B52AA6E4}">
+                <adec:decorative xmlns:adec="http://schemas.microsoft.com/office/drawing/2017/decorative" val="1"/>
+              </a:ext>
+            </a:extLst>
+          </p:cNvPr>
+          <p:cNvSpPr>
+            <a:spLocks noGrp="1" noRot="1" noChangeAspect="1" noMove="1" noResize="1" noEditPoints="1" noAdjustHandles="1" noChangeArrowheads="1" noChangeShapeType="1" noTextEdit="1"/>
+          </p:cNvSpPr>
+          <p:nvPr>
+            <p:extLst>
+              <p:ext uri="{386F3935-93C4-4BCD-93E2-E3B085C9AB24}">
+                <p16:designElem xmlns:p16="http://schemas.microsoft.com/office/powerpoint/2015/main" val="1"/>
+              </p:ext>
+            </p:extLst>
+          </p:nvPr>
+        </p:nvSpPr>
+        <p:spPr>
+          <a:xfrm>
+            <a:off x="8042147" y="723899"/>
+            <a:ext cx="3703320" cy="5666666"/>
+          </a:xfrm>
+          <a:prstGeom prst="rect">
+            <a:avLst/>
+          </a:prstGeom>
+          <a:solidFill>
+            <a:schemeClr val="accent1"/>
+          </a:solidFill>
+          <a:ln>
+            <a:noFill/>
+          </a:ln>
+          <a:effectLst/>
+        </p:spPr>
+        <p:style>
+          <a:lnRef idx="1">
+            <a:schemeClr val="accent1"/>
+          </a:lnRef>
+          <a:fillRef idx="3">
+            <a:schemeClr val="accent1"/>
+          </a:fillRef>
+          <a:effectRef idx="2">
+            <a:schemeClr val="accent1"/>
+          </a:effectRef>
+          <a:fontRef idx="minor">
+            <a:schemeClr val="lt1"/>
+          </a:fontRef>
+        </p:style>
+      </p:sp>
+      <p:sp>
+        <p:nvSpPr>
           <p:cNvPr id="2" name="Titel 1">
             <a:extLst>
               <a:ext uri="{FF2B5EF4-FFF2-40B4-BE49-F238E27FC236}">
-                <a16:creationId xmlns:a16="http://schemas.microsoft.com/office/drawing/2014/main" id="{77F35C1F-972A-C941-35DE-AF62475894C6}"/>
+                <a16:creationId xmlns:a16="http://schemas.microsoft.com/office/drawing/2014/main" id="{176DFBAE-5471-E50C-F7BA-BA95A0C276DF}"/>
               </a:ext>
             </a:extLst>
           </p:cNvPr>
@@ -11496,63 +13078,324 @@
             <p:ph type="title"/>
           </p:nvPr>
         </p:nvSpPr>
-        <p:spPr/>
+        <p:spPr>
+          <a:xfrm>
+            <a:off x="8296275" y="1419225"/>
+            <a:ext cx="3081576" cy="2085869"/>
+          </a:xfrm>
+        </p:spPr>
         <p:txBody>
-          <a:bodyPr rtlCol="0"/>
+          <a:bodyPr vert="horz" lIns="91440" tIns="45720" rIns="91440" bIns="45720" rtlCol="0" anchor="b">
+            <a:normAutofit/>
+          </a:bodyPr>
           <a:lstStyle/>
           <a:p>
-            <a:pPr rtl="0"/>
             <a:r>
-              <a:rPr lang="de-DE" dirty="0"/>
-              <a:t>Interpretation der Ergebnisse</a:t>
+              <a:rPr lang="en-US" sz="3600">
+                <a:solidFill>
+                  <a:srgbClr val="FFFFFF"/>
+                </a:solidFill>
+              </a:rPr>
+              <a:t>Q_iI</a:t>
             </a:r>
+            <a:endParaRPr lang="en-US" sz="3600" dirty="0">
+              <a:solidFill>
+                <a:srgbClr val="FFFFFF"/>
+              </a:solidFill>
+            </a:endParaRPr>
           </a:p>
         </p:txBody>
       </p:sp>
-      <p:sp>
-        <p:nvSpPr>
-          <p:cNvPr id="6" name="Inhaltsplatzhalter 5">
+      <p:grpSp>
+        <p:nvGrpSpPr>
+          <p:cNvPr id="44" name="Group 43">
             <a:extLst>
               <a:ext uri="{FF2B5EF4-FFF2-40B4-BE49-F238E27FC236}">
-                <a16:creationId xmlns:a16="http://schemas.microsoft.com/office/drawing/2014/main" id="{AEBB9406-CC1C-8F1C-DA12-7C6E38358CBB}"/>
+                <a16:creationId xmlns:a16="http://schemas.microsoft.com/office/drawing/2014/main" id="{9A421166-2996-41A7-B094-AE5316F347DD}"/>
+              </a:ext>
+              <a:ext uri="{C183D7F6-B498-43B3-948B-1728B52AA6E4}">
+                <adec:decorative xmlns:adec="http://schemas.microsoft.com/office/drawing/2017/decorative" val="1"/>
               </a:ext>
             </a:extLst>
           </p:cNvPr>
-          <p:cNvSpPr>
-            <a:spLocks noGrp="1"/>
-          </p:cNvSpPr>
-          <p:nvPr>
-            <p:ph sz="half" idx="2"/>
-          </p:nvPr>
-        </p:nvSpPr>
-        <p:spPr>
+          <p:cNvGrpSpPr>
+            <a:grpSpLocks noGrp="1" noUngrp="1" noRot="1" noChangeAspect="1" noMove="1" noResize="1"/>
+          </p:cNvGrpSpPr>
+          <p:nvPr>
+            <p:extLst>
+              <p:ext uri="{386F3935-93C4-4BCD-93E2-E3B085C9AB24}">
+                <p16:designElem xmlns:p16="http://schemas.microsoft.com/office/powerpoint/2015/main" val="1"/>
+              </p:ext>
+            </p:extLst>
+          </p:nvPr>
+        </p:nvGrpSpPr>
+        <p:grpSpPr>
           <a:xfrm>
-            <a:off x="581193" y="2228003"/>
-            <a:ext cx="11029616" cy="3633047"/>
+            <a:off x="446534" y="453643"/>
+            <a:ext cx="11298933" cy="98554"/>
+            <a:chOff x="446534" y="453643"/>
+            <a:chExt cx="11298933" cy="98554"/>
           </a:xfrm>
-        </p:spPr>
-        <p:txBody>
-          <a:bodyPr/>
-          <a:lstStyle/>
-          <a:p>
-            <a:r>
-              <a:rPr lang="de-AT" dirty="0" err="1"/>
-              <a:t>test</a:t>
-            </a:r>
-            <a:endParaRPr lang="de-AT" dirty="0"/>
-          </a:p>
-        </p:txBody>
-      </p:sp>
+        </p:grpSpPr>
+        <p:sp>
+          <p:nvSpPr>
+            <p:cNvPr id="45" name="Rectangle 44">
+              <a:extLst>
+                <a:ext uri="{FF2B5EF4-FFF2-40B4-BE49-F238E27FC236}">
+                  <a16:creationId xmlns:a16="http://schemas.microsoft.com/office/drawing/2014/main" id="{FDBB1B92-A3EB-43E4-8FAB-D20E8ED14CEF}"/>
+                </a:ext>
+                <a:ext uri="{C183D7F6-B498-43B3-948B-1728B52AA6E4}">
+                  <adec:decorative xmlns:adec="http://schemas.microsoft.com/office/drawing/2017/decorative" val="1"/>
+                </a:ext>
+              </a:extLst>
+            </p:cNvPr>
+            <p:cNvSpPr/>
+            <p:nvPr>
+              <p:extLst>
+                <p:ext uri="{386F3935-93C4-4BCD-93E2-E3B085C9AB24}">
+                  <p16:designElem xmlns:p16="http://schemas.microsoft.com/office/powerpoint/2015/main" val="1"/>
+                </p:ext>
+              </p:extLst>
+            </p:nvPr>
+          </p:nvSpPr>
+          <p:spPr>
+            <a:xfrm>
+              <a:off x="446534" y="457200"/>
+              <a:ext cx="3703320" cy="94997"/>
+            </a:xfrm>
+            <a:prstGeom prst="rect">
+              <a:avLst/>
+            </a:prstGeom>
+            <a:solidFill>
+              <a:schemeClr val="accent1"/>
+            </a:solidFill>
+            <a:ln>
+              <a:noFill/>
+            </a:ln>
+            <a:effectLst/>
+          </p:spPr>
+          <p:style>
+            <a:lnRef idx="1">
+              <a:schemeClr val="accent1"/>
+            </a:lnRef>
+            <a:fillRef idx="3">
+              <a:schemeClr val="accent1"/>
+            </a:fillRef>
+            <a:effectRef idx="2">
+              <a:schemeClr val="accent1"/>
+            </a:effectRef>
+            <a:fontRef idx="minor">
+              <a:schemeClr val="lt1"/>
+            </a:fontRef>
+          </p:style>
+        </p:sp>
+        <p:sp>
+          <p:nvSpPr>
+            <p:cNvPr id="46" name="Rectangle 45">
+              <a:extLst>
+                <a:ext uri="{FF2B5EF4-FFF2-40B4-BE49-F238E27FC236}">
+                  <a16:creationId xmlns:a16="http://schemas.microsoft.com/office/drawing/2014/main" id="{3F3972F4-FE7E-48EA-AAD8-9BE5750A6672}"/>
+                </a:ext>
+                <a:ext uri="{C183D7F6-B498-43B3-948B-1728B52AA6E4}">
+                  <adec:decorative xmlns:adec="http://schemas.microsoft.com/office/drawing/2017/decorative" val="1"/>
+                </a:ext>
+              </a:extLst>
+            </p:cNvPr>
+            <p:cNvSpPr/>
+            <p:nvPr>
+              <p:extLst>
+                <p:ext uri="{386F3935-93C4-4BCD-93E2-E3B085C9AB24}">
+                  <p16:designElem xmlns:p16="http://schemas.microsoft.com/office/powerpoint/2015/main" val="1"/>
+                </p:ext>
+              </p:extLst>
+            </p:nvPr>
+          </p:nvSpPr>
+          <p:spPr>
+            <a:xfrm>
+              <a:off x="8042147" y="453643"/>
+              <a:ext cx="3703320" cy="98554"/>
+            </a:xfrm>
+            <a:prstGeom prst="rect">
+              <a:avLst/>
+            </a:prstGeom>
+            <a:solidFill>
+              <a:schemeClr val="accent4"/>
+            </a:solidFill>
+            <a:ln>
+              <a:noFill/>
+            </a:ln>
+            <a:effectLst/>
+          </p:spPr>
+          <p:style>
+            <a:lnRef idx="1">
+              <a:schemeClr val="accent1"/>
+            </a:lnRef>
+            <a:fillRef idx="3">
+              <a:schemeClr val="accent1"/>
+            </a:fillRef>
+            <a:effectRef idx="2">
+              <a:schemeClr val="accent1"/>
+            </a:effectRef>
+            <a:fontRef idx="minor">
+              <a:schemeClr val="lt1"/>
+            </a:fontRef>
+          </p:style>
+        </p:sp>
+        <p:sp>
+          <p:nvSpPr>
+            <p:cNvPr id="47" name="Rectangle 46">
+              <a:extLst>
+                <a:ext uri="{FF2B5EF4-FFF2-40B4-BE49-F238E27FC236}">
+                  <a16:creationId xmlns:a16="http://schemas.microsoft.com/office/drawing/2014/main" id="{221614E5-870B-4D5E-A43B-8FF7E5323484}"/>
+                </a:ext>
+                <a:ext uri="{C183D7F6-B498-43B3-948B-1728B52AA6E4}">
+                  <adec:decorative xmlns:adec="http://schemas.microsoft.com/office/drawing/2017/decorative" val="1"/>
+                </a:ext>
+              </a:extLst>
+            </p:cNvPr>
+            <p:cNvSpPr/>
+            <p:nvPr>
+              <p:extLst>
+                <p:ext uri="{386F3935-93C4-4BCD-93E2-E3B085C9AB24}">
+                  <p16:designElem xmlns:p16="http://schemas.microsoft.com/office/powerpoint/2015/main" val="1"/>
+                </p:ext>
+              </p:extLst>
+            </p:nvPr>
+          </p:nvSpPr>
+          <p:spPr>
+            <a:xfrm>
+              <a:off x="4241830" y="457200"/>
+              <a:ext cx="3703320" cy="91440"/>
+            </a:xfrm>
+            <a:prstGeom prst="rect">
+              <a:avLst/>
+            </a:prstGeom>
+            <a:solidFill>
+              <a:schemeClr val="accent2"/>
+            </a:solidFill>
+            <a:ln>
+              <a:noFill/>
+            </a:ln>
+            <a:effectLst/>
+          </p:spPr>
+          <p:style>
+            <a:lnRef idx="1">
+              <a:schemeClr val="accent1"/>
+            </a:lnRef>
+            <a:fillRef idx="3">
+              <a:schemeClr val="accent1"/>
+            </a:fillRef>
+            <a:effectRef idx="2">
+              <a:schemeClr val="accent1"/>
+            </a:effectRef>
+            <a:fontRef idx="minor">
+              <a:schemeClr val="lt1"/>
+            </a:fontRef>
+          </p:style>
+        </p:sp>
+      </p:grpSp>
     </p:spTree>
     <p:extLst>
       <p:ext uri="{BB962C8B-B14F-4D97-AF65-F5344CB8AC3E}">
-        <p14:creationId xmlns:p14="http://schemas.microsoft.com/office/powerpoint/2010/main" val="1747102689"/>
+        <p14:creationId xmlns:p14="http://schemas.microsoft.com/office/powerpoint/2010/main" val="2045613644"/>
       </p:ext>
     </p:extLst>
   </p:cSld>
   <p:clrMapOvr>
     <a:masterClrMapping/>
   </p:clrMapOvr>
+  <p:timing>
+    <p:tnLst>
+      <p:par>
+        <p:cTn id="1" dur="indefinite" restart="never" nodeType="tmRoot">
+          <p:childTnLst>
+            <p:seq concurrent="1" nextAc="seek">
+              <p:cTn id="2" dur="indefinite" nodeType="mainSeq">
+                <p:childTnLst>
+                  <p:par>
+                    <p:cTn id="3" fill="hold">
+                      <p:stCondLst>
+                        <p:cond delay="indefinite"/>
+                        <p:cond evt="onBegin" delay="0">
+                          <p:tn val="2"/>
+                        </p:cond>
+                      </p:stCondLst>
+                      <p:childTnLst>
+                        <p:par>
+                          <p:cTn id="4" fill="hold">
+                            <p:stCondLst>
+                              <p:cond delay="0"/>
+                            </p:stCondLst>
+                            <p:childTnLst>
+                              <p:par>
+                                <p:cTn id="5" presetID="10" presetClass="entr" presetSubtype="0" fill="hold" grpId="0" nodeType="withEffect">
+                                  <p:stCondLst>
+                                    <p:cond delay="1000"/>
+                                  </p:stCondLst>
+                                  <p:iterate type="lt">
+                                    <p:tmPct val="10000"/>
+                                  </p:iterate>
+                                  <p:childTnLst>
+                                    <p:set>
+                                      <p:cBhvr>
+                                        <p:cTn id="6" dur="1" fill="hold">
+                                          <p:stCondLst>
+                                            <p:cond delay="0"/>
+                                          </p:stCondLst>
+                                        </p:cTn>
+                                        <p:tgtEl>
+                                          <p:spTgt spid="2"/>
+                                        </p:tgtEl>
+                                        <p:attrNameLst>
+                                          <p:attrName>style.visibility</p:attrName>
+                                        </p:attrNameLst>
+                                      </p:cBhvr>
+                                      <p:to>
+                                        <p:strVal val="visible"/>
+                                      </p:to>
+                                    </p:set>
+                                    <p:animEffect transition="in" filter="fade">
+                                      <p:cBhvr>
+                                        <p:cTn id="7" dur="400"/>
+                                        <p:tgtEl>
+                                          <p:spTgt spid="2"/>
+                                        </p:tgtEl>
+                                      </p:cBhvr>
+                                    </p:animEffect>
+                                  </p:childTnLst>
+                                </p:cTn>
+                              </p:par>
+                            </p:childTnLst>
+                          </p:cTn>
+                        </p:par>
+                      </p:childTnLst>
+                    </p:cTn>
+                  </p:par>
+                </p:childTnLst>
+              </p:cTn>
+              <p:prevCondLst>
+                <p:cond evt="onPrev" delay="0">
+                  <p:tgtEl>
+                    <p:sldTgt/>
+                  </p:tgtEl>
+                </p:cond>
+              </p:prevCondLst>
+              <p:nextCondLst>
+                <p:cond evt="onNext" delay="0">
+                  <p:tgtEl>
+                    <p:sldTgt/>
+                  </p:tgtEl>
+                </p:cond>
+              </p:nextCondLst>
+            </p:seq>
+          </p:childTnLst>
+        </p:cTn>
+      </p:par>
+    </p:tnLst>
+    <p:bldLst>
+      <p:bldP spid="2" grpId="0"/>
+    </p:bldLst>
+  </p:timing>
 </p:sld>
 </file>
 
@@ -12416,6 +14259,14 @@
 </file>
 
 <file path=customXml/item1.xml><?xml version="1.0" encoding="utf-8"?>
+<p:properties xmlns:p="http://schemas.microsoft.com/office/2006/metadata/properties" xmlns:xsi="http://www.w3.org/2001/XMLSchema-instance" xmlns:pc="http://schemas.microsoft.com/office/infopath/2007/PartnerControls">
+  <documentManagement>
+    <MediaServiceKeyPoints xmlns="71af3243-3dd4-4a8d-8c0d-dd76da1f02a5" xsi:nil="true"/>
+  </documentManagement>
+</p:properties>
+</file>
+
+<file path=customXml/item2.xml><?xml version="1.0" encoding="utf-8"?>
 <ct:contentTypeSchema xmlns:ct="http://schemas.microsoft.com/office/2006/metadata/contentType" xmlns:ma="http://schemas.microsoft.com/office/2006/metadata/properties/metaAttributes" ct:_="" ma:_="" ma:contentTypeName="Document" ma:contentTypeID="0x01010079F111ED35F8CC479449609E8A0923A6" ma:contentTypeVersion="11" ma:contentTypeDescription="Create a new document." ma:contentTypeScope="" ma:versionID="1c2eb7a32e66fb6e4260f3771546a5e2">
   <xsd:schema xmlns:xsd="http://www.w3.org/2001/XMLSchema" xmlns:xs="http://www.w3.org/2001/XMLSchema" xmlns:p="http://schemas.microsoft.com/office/2006/metadata/properties" xmlns:ns2="71af3243-3dd4-4a8d-8c0d-dd76da1f02a5" xmlns:ns3="16c05727-aa75-4e4a-9b5f-8a80a1165891" targetNamespace="http://schemas.microsoft.com/office/2006/metadata/properties" ma:root="true" ma:fieldsID="04e1f6479c48b08974ba73b5ca973489" ns2:_="" ns3:_="">
     <xsd:import namespace="71af3243-3dd4-4a8d-8c0d-dd76da1f02a5"/>
@@ -12626,14 +14477,6 @@
 </ct:contentTypeSchema>
 </file>
 
-<file path=customXml/item2.xml><?xml version="1.0" encoding="utf-8"?>
-<p:properties xmlns:p="http://schemas.microsoft.com/office/2006/metadata/properties" xmlns:xsi="http://www.w3.org/2001/XMLSchema-instance" xmlns:pc="http://schemas.microsoft.com/office/infopath/2007/PartnerControls">
-  <documentManagement>
-    <MediaServiceKeyPoints xmlns="71af3243-3dd4-4a8d-8c0d-dd76da1f02a5" xsi:nil="true"/>
-  </documentManagement>
-</p:properties>
-</file>
-
 <file path=customXml/item3.xml><?xml version="1.0" encoding="utf-8"?>
 <?mso-contentType ?>
 <FormTemplates xmlns="http://schemas.microsoft.com/sharepoint/v3/contenttype/forms">
@@ -12644,6 +14487,16 @@
 </file>
 
 <file path=customXml/itemProps1.xml><?xml version="1.0" encoding="utf-8"?>
+<ds:datastoreItem xmlns:ds="http://schemas.openxmlformats.org/officeDocument/2006/customXml" ds:itemID="{1EBC12AA-1C15-4500-BC9C-8EE83A441DE9}">
+  <ds:schemaRefs>
+    <ds:schemaRef ds:uri="http://schemas.microsoft.com/office/2006/metadata/properties"/>
+    <ds:schemaRef ds:uri="http://schemas.microsoft.com/office/infopath/2007/PartnerControls"/>
+    <ds:schemaRef ds:uri="71af3243-3dd4-4a8d-8c0d-dd76da1f02a5"/>
+  </ds:schemaRefs>
+</ds:datastoreItem>
+</file>
+
+<file path=customXml/itemProps2.xml><?xml version="1.0" encoding="utf-8"?>
 <ds:datastoreItem xmlns:ds="http://schemas.openxmlformats.org/officeDocument/2006/customXml" ds:itemID="{1F69AFF4-BB30-4BA0-AD22-82CC3C43276B}">
   <ds:schemaRefs>
     <ds:schemaRef ds:uri="http://schemas.microsoft.com/office/2006/metadata/contentType"/>
@@ -12662,16 +14515,6 @@
 </ds:datastoreItem>
 </file>
 
-<file path=customXml/itemProps2.xml><?xml version="1.0" encoding="utf-8"?>
-<ds:datastoreItem xmlns:ds="http://schemas.openxmlformats.org/officeDocument/2006/customXml" ds:itemID="{1EBC12AA-1C15-4500-BC9C-8EE83A441DE9}">
-  <ds:schemaRefs>
-    <ds:schemaRef ds:uri="http://schemas.microsoft.com/office/2006/metadata/properties"/>
-    <ds:schemaRef ds:uri="http://schemas.microsoft.com/office/infopath/2007/PartnerControls"/>
-    <ds:schemaRef ds:uri="71af3243-3dd4-4a8d-8c0d-dd76da1f02a5"/>
-  </ds:schemaRefs>
-</ds:datastoreItem>
-</file>
-
 <file path=customXml/itemProps3.xml><?xml version="1.0" encoding="utf-8"?>
 <ds:datastoreItem xmlns:ds="http://schemas.openxmlformats.org/officeDocument/2006/customXml" ds:itemID="{BA0CF3B2-1F0F-4FC5-8002-3E4869ABAD55}">
   <ds:schemaRefs>

</xml_diff>